<commit_message>
Add 'What we do' section to OKR deck (4 slides: Feature/Solution/Project)
Append a What we do section covering the catchcopy, the three
environments (Tool/Place/Knowledge), the solution lineup, and the
related project list, in the same minimal style. Deck is now 14 slides.

Co-Authored-By: Claude Opus 4.8 <noreply@anthropic.com>
Claude-Session: https://claude.ai/code/session_01LmcPRN3vB6e2E59KghQDN2
</commit_message>
<xml_diff>
--- a/incubation-okr-q3-q4.pptx
+++ b/incubation-okr-q3-q4.pptx
@@ -15,9 +15,13 @@
     <p:sldId id="263" r:id="rId9"/>
     <p:sldId id="264" r:id="rId10"/>
     <p:sldId id="265" r:id="rId11"/>
+    <p:sldId id="266" r:id="rId12"/>
+    <p:sldId id="267" r:id="rId13"/>
+    <p:sldId id="268" r:id="rId14"/>
+    <p:sldId id="269" r:id="rId15"/>
   </p:sldIdLst>
   <p:notesMasterIdLst>
-    <p:notesMasterId r:id="rId12"/>
+    <p:notesMasterId r:id="rId16"/>
   </p:notesMasterIdLst>
   <p:sldSz cx="12191695" cy="6858000"/>
   <p:notesSz cx="6858000" cy="12191695"/>
@@ -623,6 +627,358 @@
             <a:fld id="{F7021451-1387-4CA6-816F-3879F97B5CBC}" type="slidenum">
               <a:rPr lang="en-US"/>
               <a:t>10</a:t>
+            </a:fld>
+            <a:endParaRPr lang="en-US"/>
+          </a:p>
+        </p:txBody>
+      </p:sp>
+    </p:spTree>
+    <p:extLst>
+      <p:ext uri="{BB962C8B-B14F-4D97-AF65-F5344CB8AC3E}">
+        <p14:creationId xmlns:p14="http://schemas.microsoft.com/office/powerpoint/2010/main" val="1024086991"/>
+      </p:ext>
+    </p:extLst>
+  </p:cSld>
+  <p:clrMapOvr>
+    <a:masterClrMapping/>
+  </p:clrMapOvr>
+</p:notes>
+</file>
+
+<file path=ppt/notesSlides/notesSlide11.xml><?xml version="1.0" encoding="utf-8"?>
+<p:notes xmlns:a="http://schemas.openxmlformats.org/drawingml/2006/main" xmlns:r="http://schemas.openxmlformats.org/officeDocument/2006/relationships" xmlns:p="http://schemas.openxmlformats.org/presentationml/2006/main">
+  <p:cSld>
+    <p:spTree>
+      <p:nvGrpSpPr>
+        <p:cNvPr id="1" name=""/>
+        <p:cNvGrpSpPr/>
+        <p:nvPr/>
+      </p:nvGrpSpPr>
+      <p:grpSpPr>
+        <a:xfrm>
+          <a:off x="0" y="0"/>
+          <a:ext cx="0" cy="0"/>
+          <a:chOff x="0" y="0"/>
+          <a:chExt cx="0" cy="0"/>
+        </a:xfrm>
+      </p:grpSpPr>
+      <p:sp>
+        <p:nvSpPr>
+          <p:cNvPr id="2" name="Slide Image Placeholder 1"/>
+          <p:cNvSpPr>
+            <a:spLocks noGrp="1" noRot="1" noChangeAspect="1"/>
+          </p:cNvSpPr>
+          <p:nvPr>
+            <p:ph type="sldImg"/>
+          </p:nvPr>
+        </p:nvSpPr>
+        <p:spPr/>
+      </p:sp>
+      <p:sp>
+        <p:nvSpPr>
+          <p:cNvPr id="3" name="Notes Placeholder 2"/>
+          <p:cNvSpPr>
+            <a:spLocks noGrp="1"/>
+          </p:cNvSpPr>
+          <p:nvPr>
+            <p:ph type="body" idx="1"/>
+          </p:nvPr>
+        </p:nvSpPr>
+        <p:spPr/>
+        <p:txBody>
+          <a:bodyPr/>
+          <a:lstStyle/>
+          <a:p>
+            <a:r>
+              <a:rPr lang="en-US" dirty="0"/>
+              <a:t/>
+            </a:r>
+            <a:endParaRPr lang="en-US" dirty="0"/>
+          </a:p>
+        </p:txBody>
+      </p:sp>
+      <p:sp>
+        <p:nvSpPr>
+          <p:cNvPr id="4" name="Slide Number Placeholder 3"/>
+          <p:cNvSpPr>
+            <a:spLocks noGrp="1"/>
+          </p:cNvSpPr>
+          <p:nvPr>
+            <p:ph type="sldNum" sz="quarter" idx="10"/>
+          </p:nvPr>
+        </p:nvSpPr>
+        <p:spPr/>
+        <p:txBody>
+          <a:bodyPr/>
+          <a:lstStyle/>
+          <a:p>
+            <a:fld id="{F7021451-1387-4CA6-816F-3879F97B5CBC}" type="slidenum">
+              <a:rPr lang="en-US"/>
+              <a:t>11</a:t>
+            </a:fld>
+            <a:endParaRPr lang="en-US"/>
+          </a:p>
+        </p:txBody>
+      </p:sp>
+    </p:spTree>
+    <p:extLst>
+      <p:ext uri="{BB962C8B-B14F-4D97-AF65-F5344CB8AC3E}">
+        <p14:creationId xmlns:p14="http://schemas.microsoft.com/office/powerpoint/2010/main" val="1024086991"/>
+      </p:ext>
+    </p:extLst>
+  </p:cSld>
+  <p:clrMapOvr>
+    <a:masterClrMapping/>
+  </p:clrMapOvr>
+</p:notes>
+</file>
+
+<file path=ppt/notesSlides/notesSlide12.xml><?xml version="1.0" encoding="utf-8"?>
+<p:notes xmlns:a="http://schemas.openxmlformats.org/drawingml/2006/main" xmlns:r="http://schemas.openxmlformats.org/officeDocument/2006/relationships" xmlns:p="http://schemas.openxmlformats.org/presentationml/2006/main">
+  <p:cSld>
+    <p:spTree>
+      <p:nvGrpSpPr>
+        <p:cNvPr id="1" name=""/>
+        <p:cNvGrpSpPr/>
+        <p:nvPr/>
+      </p:nvGrpSpPr>
+      <p:grpSpPr>
+        <a:xfrm>
+          <a:off x="0" y="0"/>
+          <a:ext cx="0" cy="0"/>
+          <a:chOff x="0" y="0"/>
+          <a:chExt cx="0" cy="0"/>
+        </a:xfrm>
+      </p:grpSpPr>
+      <p:sp>
+        <p:nvSpPr>
+          <p:cNvPr id="2" name="Slide Image Placeholder 1"/>
+          <p:cNvSpPr>
+            <a:spLocks noGrp="1" noRot="1" noChangeAspect="1"/>
+          </p:cNvSpPr>
+          <p:nvPr>
+            <p:ph type="sldImg"/>
+          </p:nvPr>
+        </p:nvSpPr>
+        <p:spPr/>
+      </p:sp>
+      <p:sp>
+        <p:nvSpPr>
+          <p:cNvPr id="3" name="Notes Placeholder 2"/>
+          <p:cNvSpPr>
+            <a:spLocks noGrp="1"/>
+          </p:cNvSpPr>
+          <p:nvPr>
+            <p:ph type="body" idx="1"/>
+          </p:nvPr>
+        </p:nvSpPr>
+        <p:spPr/>
+        <p:txBody>
+          <a:bodyPr/>
+          <a:lstStyle/>
+          <a:p>
+            <a:r>
+              <a:rPr lang="en-US" dirty="0"/>
+              <a:t/>
+            </a:r>
+            <a:endParaRPr lang="en-US" dirty="0"/>
+          </a:p>
+        </p:txBody>
+      </p:sp>
+      <p:sp>
+        <p:nvSpPr>
+          <p:cNvPr id="4" name="Slide Number Placeholder 3"/>
+          <p:cNvSpPr>
+            <a:spLocks noGrp="1"/>
+          </p:cNvSpPr>
+          <p:nvPr>
+            <p:ph type="sldNum" sz="quarter" idx="10"/>
+          </p:nvPr>
+        </p:nvSpPr>
+        <p:spPr/>
+        <p:txBody>
+          <a:bodyPr/>
+          <a:lstStyle/>
+          <a:p>
+            <a:fld id="{F7021451-1387-4CA6-816F-3879F97B5CBC}" type="slidenum">
+              <a:rPr lang="en-US"/>
+              <a:t>12</a:t>
+            </a:fld>
+            <a:endParaRPr lang="en-US"/>
+          </a:p>
+        </p:txBody>
+      </p:sp>
+    </p:spTree>
+    <p:extLst>
+      <p:ext uri="{BB962C8B-B14F-4D97-AF65-F5344CB8AC3E}">
+        <p14:creationId xmlns:p14="http://schemas.microsoft.com/office/powerpoint/2010/main" val="1024086991"/>
+      </p:ext>
+    </p:extLst>
+  </p:cSld>
+  <p:clrMapOvr>
+    <a:masterClrMapping/>
+  </p:clrMapOvr>
+</p:notes>
+</file>
+
+<file path=ppt/notesSlides/notesSlide13.xml><?xml version="1.0" encoding="utf-8"?>
+<p:notes xmlns:a="http://schemas.openxmlformats.org/drawingml/2006/main" xmlns:r="http://schemas.openxmlformats.org/officeDocument/2006/relationships" xmlns:p="http://schemas.openxmlformats.org/presentationml/2006/main">
+  <p:cSld>
+    <p:spTree>
+      <p:nvGrpSpPr>
+        <p:cNvPr id="1" name=""/>
+        <p:cNvGrpSpPr/>
+        <p:nvPr/>
+      </p:nvGrpSpPr>
+      <p:grpSpPr>
+        <a:xfrm>
+          <a:off x="0" y="0"/>
+          <a:ext cx="0" cy="0"/>
+          <a:chOff x="0" y="0"/>
+          <a:chExt cx="0" cy="0"/>
+        </a:xfrm>
+      </p:grpSpPr>
+      <p:sp>
+        <p:nvSpPr>
+          <p:cNvPr id="2" name="Slide Image Placeholder 1"/>
+          <p:cNvSpPr>
+            <a:spLocks noGrp="1" noRot="1" noChangeAspect="1"/>
+          </p:cNvSpPr>
+          <p:nvPr>
+            <p:ph type="sldImg"/>
+          </p:nvPr>
+        </p:nvSpPr>
+        <p:spPr/>
+      </p:sp>
+      <p:sp>
+        <p:nvSpPr>
+          <p:cNvPr id="3" name="Notes Placeholder 2"/>
+          <p:cNvSpPr>
+            <a:spLocks noGrp="1"/>
+          </p:cNvSpPr>
+          <p:nvPr>
+            <p:ph type="body" idx="1"/>
+          </p:nvPr>
+        </p:nvSpPr>
+        <p:spPr/>
+        <p:txBody>
+          <a:bodyPr/>
+          <a:lstStyle/>
+          <a:p>
+            <a:r>
+              <a:rPr lang="en-US" dirty="0"/>
+              <a:t/>
+            </a:r>
+            <a:endParaRPr lang="en-US" dirty="0"/>
+          </a:p>
+        </p:txBody>
+      </p:sp>
+      <p:sp>
+        <p:nvSpPr>
+          <p:cNvPr id="4" name="Slide Number Placeholder 3"/>
+          <p:cNvSpPr>
+            <a:spLocks noGrp="1"/>
+          </p:cNvSpPr>
+          <p:nvPr>
+            <p:ph type="sldNum" sz="quarter" idx="10"/>
+          </p:nvPr>
+        </p:nvSpPr>
+        <p:spPr/>
+        <p:txBody>
+          <a:bodyPr/>
+          <a:lstStyle/>
+          <a:p>
+            <a:fld id="{F7021451-1387-4CA6-816F-3879F97B5CBC}" type="slidenum">
+              <a:rPr lang="en-US"/>
+              <a:t>13</a:t>
+            </a:fld>
+            <a:endParaRPr lang="en-US"/>
+          </a:p>
+        </p:txBody>
+      </p:sp>
+    </p:spTree>
+    <p:extLst>
+      <p:ext uri="{BB962C8B-B14F-4D97-AF65-F5344CB8AC3E}">
+        <p14:creationId xmlns:p14="http://schemas.microsoft.com/office/powerpoint/2010/main" val="1024086991"/>
+      </p:ext>
+    </p:extLst>
+  </p:cSld>
+  <p:clrMapOvr>
+    <a:masterClrMapping/>
+  </p:clrMapOvr>
+</p:notes>
+</file>
+
+<file path=ppt/notesSlides/notesSlide14.xml><?xml version="1.0" encoding="utf-8"?>
+<p:notes xmlns:a="http://schemas.openxmlformats.org/drawingml/2006/main" xmlns:r="http://schemas.openxmlformats.org/officeDocument/2006/relationships" xmlns:p="http://schemas.openxmlformats.org/presentationml/2006/main">
+  <p:cSld>
+    <p:spTree>
+      <p:nvGrpSpPr>
+        <p:cNvPr id="1" name=""/>
+        <p:cNvGrpSpPr/>
+        <p:nvPr/>
+      </p:nvGrpSpPr>
+      <p:grpSpPr>
+        <a:xfrm>
+          <a:off x="0" y="0"/>
+          <a:ext cx="0" cy="0"/>
+          <a:chOff x="0" y="0"/>
+          <a:chExt cx="0" cy="0"/>
+        </a:xfrm>
+      </p:grpSpPr>
+      <p:sp>
+        <p:nvSpPr>
+          <p:cNvPr id="2" name="Slide Image Placeholder 1"/>
+          <p:cNvSpPr>
+            <a:spLocks noGrp="1" noRot="1" noChangeAspect="1"/>
+          </p:cNvSpPr>
+          <p:nvPr>
+            <p:ph type="sldImg"/>
+          </p:nvPr>
+        </p:nvSpPr>
+        <p:spPr/>
+      </p:sp>
+      <p:sp>
+        <p:nvSpPr>
+          <p:cNvPr id="3" name="Notes Placeholder 2"/>
+          <p:cNvSpPr>
+            <a:spLocks noGrp="1"/>
+          </p:cNvSpPr>
+          <p:nvPr>
+            <p:ph type="body" idx="1"/>
+          </p:nvPr>
+        </p:nvSpPr>
+        <p:spPr/>
+        <p:txBody>
+          <a:bodyPr/>
+          <a:lstStyle/>
+          <a:p>
+            <a:r>
+              <a:rPr lang="en-US" dirty="0"/>
+              <a:t/>
+            </a:r>
+            <a:endParaRPr lang="en-US" dirty="0"/>
+          </a:p>
+        </p:txBody>
+      </p:sp>
+      <p:sp>
+        <p:nvSpPr>
+          <p:cNvPr id="4" name="Slide Number Placeholder 3"/>
+          <p:cNvSpPr>
+            <a:spLocks noGrp="1"/>
+          </p:cNvSpPr>
+          <p:nvPr>
+            <p:ph type="sldNum" sz="quarter" idx="10"/>
+          </p:nvPr>
+        </p:nvSpPr>
+        <p:spPr/>
+        <p:txBody>
+          <a:bodyPr/>
+          <a:lstStyle/>
+          <a:p>
+            <a:fld id="{F7021451-1387-4CA6-816F-3879F97B5CBC}" type="slidenum">
+              <a:rPr lang="en-US"/>
+              <a:t>14</a:t>
             </a:fld>
             <a:endParaRPr lang="en-US"/>
           </a:p>
@@ -2731,6 +3087,4139 @@
 </p:sld>
 </file>
 
+<file path=ppt/slides/slide11.xml><?xml version="1.0" encoding="utf-8"?>
+<p:sld xmlns:a="http://schemas.openxmlformats.org/drawingml/2006/main" xmlns:r="http://schemas.openxmlformats.org/officeDocument/2006/relationships" xmlns:p="http://schemas.openxmlformats.org/presentationml/2006/main">
+  <p:cSld name="Slide 11">
+    <p:bg>
+      <p:bgPr>
+        <a:solidFill>
+          <a:srgbClr val="FDFCFA"/>
+        </a:solidFill>
+      </p:bgPr>
+    </p:bg>
+    <p:spTree>
+      <p:nvGrpSpPr>
+        <p:cNvPr id="1" name=""/>
+        <p:cNvGrpSpPr/>
+        <p:nvPr/>
+      </p:nvGrpSpPr>
+      <p:grpSpPr>
+        <a:xfrm>
+          <a:off x="0" y="0"/>
+          <a:ext cx="0" cy="0"/>
+          <a:chOff x="0" y="0"/>
+          <a:chExt cx="0" cy="0"/>
+        </a:xfrm>
+      </p:grpSpPr>
+      <p:sp>
+        <p:nvSpPr>
+          <p:cNvPr id="2" name="Shape 0"/>
+          <p:cNvSpPr/>
+          <p:nvPr/>
+        </p:nvSpPr>
+        <p:spPr>
+          <a:xfrm>
+            <a:off x="0" y="0"/>
+            <a:ext cx="201168" cy="6858000"/>
+          </a:xfrm>
+          <a:prstGeom prst="rect">
+            <a:avLst/>
+          </a:prstGeom>
+          <a:solidFill>
+            <a:srgbClr val="B8772E"/>
+          </a:solidFill>
+          <a:ln/>
+        </p:spPr>
+      </p:sp>
+      <p:sp>
+        <p:nvSpPr>
+          <p:cNvPr id="3" name="Text 1"/>
+          <p:cNvSpPr/>
+          <p:nvPr/>
+        </p:nvSpPr>
+        <p:spPr>
+          <a:xfrm>
+            <a:off x="978408" y="1783080"/>
+            <a:ext cx="9144000" cy="457200"/>
+          </a:xfrm>
+          <a:prstGeom prst="rect">
+            <a:avLst/>
+          </a:prstGeom>
+          <a:noFill/>
+          <a:ln/>
+        </p:spPr>
+        <p:txBody>
+          <a:bodyPr wrap="square" lIns="0" tIns="0" rIns="0" bIns="0" rtlCol="0" anchor="t"/>
+          <a:lstStyle/>
+          <a:p>
+            <a:pPr indent="0" marL="0">
+              <a:buNone/>
+            </a:pPr>
+            <a:r>
+              <a:rPr lang="en-US" sz="1500" b="1" dirty="0">
+                <a:solidFill>
+                  <a:srgbClr val="B8772E"/>
+                </a:solidFill>
+                <a:latin typeface="Yu Gothic" pitchFamily="34" charset="0"/>
+                <a:ea typeface="Yu Gothic" pitchFamily="34" charset="-122"/>
+                <a:cs typeface="Yu Gothic" pitchFamily="34" charset="-120"/>
+              </a:rPr>
+              <a:t>WHAT WE DO</a:t>
+            </a:r>
+            <a:endParaRPr lang="en-US" sz="1500" dirty="0"/>
+          </a:p>
+        </p:txBody>
+      </p:sp>
+      <p:sp>
+        <p:nvSpPr>
+          <p:cNvPr id="4" name="Text 2"/>
+          <p:cNvSpPr/>
+          <p:nvPr/>
+        </p:nvSpPr>
+        <p:spPr>
+          <a:xfrm>
+            <a:off x="978408" y="2331720"/>
+            <a:ext cx="10424160" cy="1097280"/>
+          </a:xfrm>
+          <a:prstGeom prst="rect">
+            <a:avLst/>
+          </a:prstGeom>
+          <a:noFill/>
+          <a:ln/>
+        </p:spPr>
+        <p:txBody>
+          <a:bodyPr wrap="square" lIns="0" tIns="0" rIns="0" bIns="0" rtlCol="0" anchor="t"/>
+          <a:lstStyle/>
+          <a:p>
+            <a:pPr indent="0" marL="0">
+              <a:lnSpc>
+                <a:spcPct val="110000"/>
+              </a:lnSpc>
+              <a:buNone/>
+            </a:pPr>
+            <a:r>
+              <a:rPr lang="en-US" sz="4000" b="1" dirty="0">
+                <a:solidFill>
+                  <a:srgbClr val="222222"/>
+                </a:solidFill>
+                <a:latin typeface="Yu Gothic" pitchFamily="34" charset="0"/>
+                <a:ea typeface="Yu Gothic" pitchFamily="34" charset="-122"/>
+                <a:cs typeface="Yu Gothic" pitchFamily="34" charset="-120"/>
+              </a:rPr>
+              <a:t>すべての人に、自由なものづくりを</a:t>
+            </a:r>
+            <a:endParaRPr lang="en-US" sz="4000" dirty="0"/>
+          </a:p>
+        </p:txBody>
+      </p:sp>
+      <p:sp>
+        <p:nvSpPr>
+          <p:cNvPr id="5" name="Shape 3"/>
+          <p:cNvSpPr/>
+          <p:nvPr/>
+        </p:nvSpPr>
+        <p:spPr>
+          <a:xfrm>
+            <a:off x="996696" y="3611880"/>
+            <a:ext cx="1828800" cy="45720"/>
+          </a:xfrm>
+          <a:prstGeom prst="rect">
+            <a:avLst/>
+          </a:prstGeom>
+          <a:solidFill>
+            <a:srgbClr val="E4E1DC"/>
+          </a:solidFill>
+          <a:ln/>
+        </p:spPr>
+      </p:sp>
+      <p:sp>
+        <p:nvSpPr>
+          <p:cNvPr id="6" name="Text 4"/>
+          <p:cNvSpPr/>
+          <p:nvPr/>
+        </p:nvSpPr>
+        <p:spPr>
+          <a:xfrm>
+            <a:off x="978408" y="3840480"/>
+            <a:ext cx="9692640" cy="1371600"/>
+          </a:xfrm>
+          <a:prstGeom prst="rect">
+            <a:avLst/>
+          </a:prstGeom>
+          <a:noFill/>
+          <a:ln/>
+        </p:spPr>
+        <p:txBody>
+          <a:bodyPr wrap="square" lIns="0" tIns="0" rIns="0" bIns="0" rtlCol="0" anchor="t"/>
+          <a:lstStyle/>
+          <a:p>
+            <a:pPr indent="0" marL="0">
+              <a:lnSpc>
+                <a:spcPct val="140000"/>
+              </a:lnSpc>
+              <a:buNone/>
+            </a:pPr>
+            <a:r>
+              <a:rPr lang="en-US" sz="1800" dirty="0">
+                <a:solidFill>
+                  <a:srgbClr val="707070"/>
+                </a:solidFill>
+                <a:latin typeface="Yu Gothic" pitchFamily="34" charset="0"/>
+                <a:ea typeface="Yu Gothic" pitchFamily="34" charset="-122"/>
+                <a:cs typeface="Yu Gothic" pitchFamily="34" charset="-120"/>
+              </a:rPr>
+              <a:t>道具・場・知識。その3つが揃ったとき、はじめて自由なものづくりが生まれる。</a:t>
+            </a:r>
+            <a:endParaRPr lang="en-US" sz="1800" dirty="0"/>
+          </a:p>
+          <a:p>
+            <a:pPr indent="0" marL="0">
+              <a:lnSpc>
+                <a:spcPct val="140000"/>
+              </a:lnSpc>
+              <a:buNone/>
+            </a:pPr>
+            <a:r>
+              <a:rPr lang="en-US" sz="1800" dirty="0">
+                <a:solidFill>
+                  <a:srgbClr val="707070"/>
+                </a:solidFill>
+                <a:latin typeface="Yu Gothic" pitchFamily="34" charset="0"/>
+                <a:ea typeface="Yu Gothic" pitchFamily="34" charset="-122"/>
+                <a:cs typeface="Yu Gothic" pitchFamily="34" charset="-120"/>
+              </a:rPr>
+              <a:t>VUILDはその環境ごと、設計する。</a:t>
+            </a:r>
+            <a:endParaRPr lang="en-US" sz="1800" dirty="0"/>
+          </a:p>
+        </p:txBody>
+      </p:sp>
+      <p:sp>
+        <p:nvSpPr>
+          <p:cNvPr id="7" name="Text 5"/>
+          <p:cNvSpPr/>
+          <p:nvPr/>
+        </p:nvSpPr>
+        <p:spPr>
+          <a:xfrm>
+            <a:off x="841248" y="6400800"/>
+            <a:ext cx="7315200" cy="274320"/>
+          </a:xfrm>
+          <a:prstGeom prst="rect">
+            <a:avLst/>
+          </a:prstGeom>
+          <a:noFill/>
+          <a:ln/>
+        </p:spPr>
+        <p:txBody>
+          <a:bodyPr wrap="square" lIns="0" tIns="0" rIns="0" bIns="0" rtlCol="0" anchor="t"/>
+          <a:lstStyle/>
+          <a:p>
+            <a:pPr indent="0" marL="0">
+              <a:buNone/>
+            </a:pPr>
+            <a:r>
+              <a:rPr lang="en-US" sz="900" dirty="0">
+                <a:solidFill>
+                  <a:srgbClr val="A8A8A8"/>
+                </a:solidFill>
+                <a:latin typeface="Yu Gothic" pitchFamily="34" charset="0"/>
+                <a:ea typeface="Yu Gothic" pitchFamily="34" charset="-122"/>
+                <a:cs typeface="Yu Gothic" pitchFamily="34" charset="-120"/>
+              </a:rPr>
+              <a:t>Incubation Team OKR ・ リーダー定例 2026-06-28</a:t>
+            </a:r>
+            <a:endParaRPr lang="en-US" sz="900" dirty="0"/>
+          </a:p>
+        </p:txBody>
+      </p:sp>
+      <p:sp>
+        <p:nvSpPr>
+          <p:cNvPr id="8" name="Text 6"/>
+          <p:cNvSpPr/>
+          <p:nvPr/>
+        </p:nvSpPr>
+        <p:spPr>
+          <a:xfrm>
+            <a:off x="10436047" y="6400800"/>
+            <a:ext cx="914400" cy="274320"/>
+          </a:xfrm>
+          <a:prstGeom prst="rect">
+            <a:avLst/>
+          </a:prstGeom>
+          <a:noFill/>
+          <a:ln/>
+        </p:spPr>
+        <p:txBody>
+          <a:bodyPr wrap="square" lIns="0" tIns="0" rIns="0" bIns="0" rtlCol="0" anchor="t"/>
+          <a:lstStyle/>
+          <a:p>
+            <a:pPr algn="r" indent="0" marL="0">
+              <a:buNone/>
+            </a:pPr>
+            <a:r>
+              <a:rPr lang="en-US" sz="900" dirty="0">
+                <a:solidFill>
+                  <a:srgbClr val="A8A8A8"/>
+                </a:solidFill>
+                <a:latin typeface="Yu Gothic" pitchFamily="34" charset="0"/>
+                <a:ea typeface="Yu Gothic" pitchFamily="34" charset="-122"/>
+                <a:cs typeface="Yu Gothic" pitchFamily="34" charset="-120"/>
+              </a:rPr>
+              <a:t>11</a:t>
+            </a:r>
+            <a:endParaRPr lang="en-US" sz="900" dirty="0"/>
+          </a:p>
+        </p:txBody>
+      </p:sp>
+    </p:spTree>
+  </p:cSld>
+  <p:clrMapOvr>
+    <a:masterClrMapping/>
+  </p:clrMapOvr>
+</p:sld>
+</file>
+
+<file path=ppt/slides/slide12.xml><?xml version="1.0" encoding="utf-8"?>
+<p:sld xmlns:a="http://schemas.openxmlformats.org/drawingml/2006/main" xmlns:r="http://schemas.openxmlformats.org/officeDocument/2006/relationships" xmlns:p="http://schemas.openxmlformats.org/presentationml/2006/main">
+  <p:cSld name="Slide 12">
+    <p:bg>
+      <p:bgPr>
+        <a:solidFill>
+          <a:srgbClr val="FDFCFA"/>
+        </a:solidFill>
+      </p:bgPr>
+    </p:bg>
+    <p:spTree>
+      <p:nvGrpSpPr>
+        <p:cNvPr id="1" name=""/>
+        <p:cNvGrpSpPr/>
+        <p:nvPr/>
+      </p:nvGrpSpPr>
+      <p:grpSpPr>
+        <a:xfrm>
+          <a:off x="0" y="0"/>
+          <a:ext cx="0" cy="0"/>
+          <a:chOff x="0" y="0"/>
+          <a:chExt cx="0" cy="0"/>
+        </a:xfrm>
+      </p:grpSpPr>
+      <p:sp>
+        <p:nvSpPr>
+          <p:cNvPr id="2" name="Shape 0"/>
+          <p:cNvSpPr/>
+          <p:nvPr/>
+        </p:nvSpPr>
+        <p:spPr>
+          <a:xfrm>
+            <a:off x="841248" y="566928"/>
+            <a:ext cx="384048" cy="77724"/>
+          </a:xfrm>
+          <a:prstGeom prst="rect">
+            <a:avLst/>
+          </a:prstGeom>
+          <a:solidFill>
+            <a:srgbClr val="B8772E"/>
+          </a:solidFill>
+          <a:ln/>
+        </p:spPr>
+      </p:sp>
+      <p:sp>
+        <p:nvSpPr>
+          <p:cNvPr id="3" name="Text 1"/>
+          <p:cNvSpPr/>
+          <p:nvPr/>
+        </p:nvSpPr>
+        <p:spPr>
+          <a:xfrm>
+            <a:off x="841248" y="731520"/>
+            <a:ext cx="10509199" cy="365760"/>
+          </a:xfrm>
+          <a:prstGeom prst="rect">
+            <a:avLst/>
+          </a:prstGeom>
+          <a:noFill/>
+          <a:ln/>
+        </p:spPr>
+        <p:txBody>
+          <a:bodyPr wrap="square" lIns="0" tIns="0" rIns="0" bIns="0" rtlCol="0" anchor="t"/>
+          <a:lstStyle/>
+          <a:p>
+            <a:pPr indent="0" marL="0">
+              <a:buNone/>
+            </a:pPr>
+            <a:r>
+              <a:rPr lang="en-US" sz="1350" b="1" dirty="0">
+                <a:solidFill>
+                  <a:srgbClr val="B8772E"/>
+                </a:solidFill>
+                <a:latin typeface="Yu Gothic" pitchFamily="34" charset="0"/>
+                <a:ea typeface="Yu Gothic" pitchFamily="34" charset="-122"/>
+                <a:cs typeface="Yu Gothic" pitchFamily="34" charset="-120"/>
+              </a:rPr>
+              <a:t>What we do ｜ Feature</a:t>
+            </a:r>
+            <a:endParaRPr lang="en-US" sz="1350" dirty="0"/>
+          </a:p>
+        </p:txBody>
+      </p:sp>
+      <p:sp>
+        <p:nvSpPr>
+          <p:cNvPr id="4" name="Text 2"/>
+          <p:cNvSpPr/>
+          <p:nvPr/>
+        </p:nvSpPr>
+        <p:spPr>
+          <a:xfrm>
+            <a:off x="841248" y="1078992"/>
+            <a:ext cx="10509199" cy="868680"/>
+          </a:xfrm>
+          <a:prstGeom prst="rect">
+            <a:avLst/>
+          </a:prstGeom>
+          <a:noFill/>
+          <a:ln/>
+        </p:spPr>
+        <p:txBody>
+          <a:bodyPr wrap="square" lIns="0" tIns="0" rIns="0" bIns="0" rtlCol="0" anchor="t"/>
+          <a:lstStyle/>
+          <a:p>
+            <a:pPr indent="0" marL="0">
+              <a:lnSpc>
+                <a:spcPct val="105000"/>
+              </a:lnSpc>
+              <a:buNone/>
+            </a:pPr>
+            <a:r>
+              <a:rPr lang="en-US" sz="2800" b="1" dirty="0">
+                <a:solidFill>
+                  <a:srgbClr val="222222"/>
+                </a:solidFill>
+                <a:latin typeface="Yu Gothic" pitchFamily="34" charset="0"/>
+                <a:ea typeface="Yu Gothic" pitchFamily="34" charset="-122"/>
+                <a:cs typeface="Yu Gothic" pitchFamily="34" charset="-120"/>
+              </a:rPr>
+              <a:t>VUILDがつくる、3つの環境</a:t>
+            </a:r>
+            <a:endParaRPr lang="en-US" sz="2800" dirty="0"/>
+          </a:p>
+        </p:txBody>
+      </p:sp>
+      <p:sp>
+        <p:nvSpPr>
+          <p:cNvPr id="5" name="Shape 3"/>
+          <p:cNvSpPr/>
+          <p:nvPr/>
+        </p:nvSpPr>
+        <p:spPr>
+          <a:xfrm>
+            <a:off x="841248" y="2057400"/>
+            <a:ext cx="3259226" cy="3840480"/>
+          </a:xfrm>
+          <a:prstGeom prst="rect">
+            <a:avLst/>
+          </a:prstGeom>
+          <a:solidFill>
+            <a:srgbClr val="FFFFFF"/>
+          </a:solidFill>
+          <a:ln w="12700">
+            <a:solidFill>
+              <a:srgbClr val="E4E1DC"/>
+            </a:solidFill>
+            <a:prstDash val="solid"/>
+          </a:ln>
+        </p:spPr>
+      </p:sp>
+      <p:sp>
+        <p:nvSpPr>
+          <p:cNvPr id="6" name="Shape 4"/>
+          <p:cNvSpPr/>
+          <p:nvPr/>
+        </p:nvSpPr>
+        <p:spPr>
+          <a:xfrm>
+            <a:off x="841248" y="2057400"/>
+            <a:ext cx="3259226" cy="82296"/>
+          </a:xfrm>
+          <a:prstGeom prst="rect">
+            <a:avLst/>
+          </a:prstGeom>
+          <a:solidFill>
+            <a:srgbClr val="B8772E"/>
+          </a:solidFill>
+          <a:ln/>
+        </p:spPr>
+      </p:sp>
+      <p:sp>
+        <p:nvSpPr>
+          <p:cNvPr id="7" name="Text 5"/>
+          <p:cNvSpPr/>
+          <p:nvPr/>
+        </p:nvSpPr>
+        <p:spPr>
+          <a:xfrm>
+            <a:off x="1115568" y="2350008"/>
+            <a:ext cx="2710586" cy="365760"/>
+          </a:xfrm>
+          <a:prstGeom prst="rect">
+            <a:avLst/>
+          </a:prstGeom>
+          <a:noFill/>
+          <a:ln/>
+        </p:spPr>
+        <p:txBody>
+          <a:bodyPr wrap="square" lIns="0" tIns="0" rIns="0" bIns="0" rtlCol="0" anchor="t"/>
+          <a:lstStyle/>
+          <a:p>
+            <a:pPr indent="0" marL="0">
+              <a:buNone/>
+            </a:pPr>
+            <a:r>
+              <a:rPr lang="en-US" sz="1500" b="1" dirty="0">
+                <a:solidFill>
+                  <a:srgbClr val="B8772E"/>
+                </a:solidFill>
+                <a:latin typeface="Yu Gothic" pitchFamily="34" charset="0"/>
+                <a:ea typeface="Yu Gothic" pitchFamily="34" charset="-122"/>
+                <a:cs typeface="Yu Gothic" pitchFamily="34" charset="-120"/>
+              </a:rPr>
+              <a:t>01. Tool</a:t>
+            </a:r>
+            <a:endParaRPr lang="en-US" sz="1500" dirty="0"/>
+          </a:p>
+        </p:txBody>
+      </p:sp>
+      <p:sp>
+        <p:nvSpPr>
+          <p:cNvPr id="8" name="Text 6"/>
+          <p:cNvSpPr/>
+          <p:nvPr/>
+        </p:nvSpPr>
+        <p:spPr>
+          <a:xfrm>
+            <a:off x="1115568" y="2807208"/>
+            <a:ext cx="2710586" cy="777240"/>
+          </a:xfrm>
+          <a:prstGeom prst="rect">
+            <a:avLst/>
+          </a:prstGeom>
+          <a:noFill/>
+          <a:ln/>
+        </p:spPr>
+        <p:txBody>
+          <a:bodyPr wrap="square" lIns="0" tIns="0" rIns="0" bIns="0" rtlCol="0" anchor="t"/>
+          <a:lstStyle/>
+          <a:p>
+            <a:pPr indent="0" marL="0">
+              <a:lnSpc>
+                <a:spcPct val="115000"/>
+              </a:lnSpc>
+              <a:buNone/>
+            </a:pPr>
+            <a:r>
+              <a:rPr lang="en-US" sz="1800" b="1" dirty="0">
+                <a:solidFill>
+                  <a:srgbClr val="222222"/>
+                </a:solidFill>
+                <a:latin typeface="Yu Gothic" pitchFamily="34" charset="0"/>
+                <a:ea typeface="Yu Gothic" pitchFamily="34" charset="-122"/>
+                <a:cs typeface="Yu Gothic" pitchFamily="34" charset="-120"/>
+              </a:rPr>
+              <a:t>アイデアを、形にする道具</a:t>
+            </a:r>
+            <a:endParaRPr lang="en-US" sz="1800" dirty="0"/>
+          </a:p>
+        </p:txBody>
+      </p:sp>
+      <p:sp>
+        <p:nvSpPr>
+          <p:cNvPr id="9" name="Text 7"/>
+          <p:cNvSpPr/>
+          <p:nvPr/>
+        </p:nvSpPr>
+        <p:spPr>
+          <a:xfrm>
+            <a:off x="1115568" y="3657600"/>
+            <a:ext cx="2710586" cy="2103120"/>
+          </a:xfrm>
+          <a:prstGeom prst="rect">
+            <a:avLst/>
+          </a:prstGeom>
+          <a:noFill/>
+          <a:ln/>
+        </p:spPr>
+        <p:txBody>
+          <a:bodyPr wrap="square" lIns="0" tIns="0" rIns="0" bIns="0" rtlCol="0" anchor="t"/>
+          <a:lstStyle/>
+          <a:p>
+            <a:pPr algn="l" indent="0" marL="0">
+              <a:lnSpc>
+                <a:spcPct val="132000"/>
+              </a:lnSpc>
+              <a:buNone/>
+            </a:pPr>
+            <a:r>
+              <a:rPr lang="en-US" sz="1150" dirty="0">
+                <a:solidFill>
+                  <a:srgbClr val="707070"/>
+                </a:solidFill>
+                <a:latin typeface="Yu Gothic" pitchFamily="34" charset="0"/>
+                <a:ea typeface="Yu Gothic" pitchFamily="34" charset="-122"/>
+                <a:cs typeface="Yu Gothic" pitchFamily="34" charset="-120"/>
+              </a:rPr>
+              <a:t>デザインから加工まで、ものづくりのプロセスをつなぐツール群を開発・提供。設計製作を補助するEMARF、木材加工を可能にするShopBot、言葉やスケッチからデザインを始められるAI Modeling Tools。3つが組み合わさることで、アイデアは形になる。</a:t>
+            </a:r>
+            <a:endParaRPr lang="en-US" sz="1150" dirty="0"/>
+          </a:p>
+        </p:txBody>
+      </p:sp>
+      <p:sp>
+        <p:nvSpPr>
+          <p:cNvPr id="10" name="Shape 8"/>
+          <p:cNvSpPr/>
+          <p:nvPr/>
+        </p:nvSpPr>
+        <p:spPr>
+          <a:xfrm>
+            <a:off x="4466234" y="2057400"/>
+            <a:ext cx="3259226" cy="3840480"/>
+          </a:xfrm>
+          <a:prstGeom prst="rect">
+            <a:avLst/>
+          </a:prstGeom>
+          <a:solidFill>
+            <a:srgbClr val="F7F2EA"/>
+          </a:solidFill>
+          <a:ln w="12700">
+            <a:solidFill>
+              <a:srgbClr val="E4E1DC"/>
+            </a:solidFill>
+            <a:prstDash val="solid"/>
+          </a:ln>
+        </p:spPr>
+      </p:sp>
+      <p:sp>
+        <p:nvSpPr>
+          <p:cNvPr id="11" name="Shape 9"/>
+          <p:cNvSpPr/>
+          <p:nvPr/>
+        </p:nvSpPr>
+        <p:spPr>
+          <a:xfrm>
+            <a:off x="4466234" y="2057400"/>
+            <a:ext cx="3259226" cy="82296"/>
+          </a:xfrm>
+          <a:prstGeom prst="rect">
+            <a:avLst/>
+          </a:prstGeom>
+          <a:solidFill>
+            <a:srgbClr val="B8772E"/>
+          </a:solidFill>
+          <a:ln/>
+        </p:spPr>
+      </p:sp>
+      <p:sp>
+        <p:nvSpPr>
+          <p:cNvPr id="12" name="Text 10"/>
+          <p:cNvSpPr/>
+          <p:nvPr/>
+        </p:nvSpPr>
+        <p:spPr>
+          <a:xfrm>
+            <a:off x="4740554" y="2350008"/>
+            <a:ext cx="2710586" cy="365760"/>
+          </a:xfrm>
+          <a:prstGeom prst="rect">
+            <a:avLst/>
+          </a:prstGeom>
+          <a:noFill/>
+          <a:ln/>
+        </p:spPr>
+        <p:txBody>
+          <a:bodyPr wrap="square" lIns="0" tIns="0" rIns="0" bIns="0" rtlCol="0" anchor="t"/>
+          <a:lstStyle/>
+          <a:p>
+            <a:pPr indent="0" marL="0">
+              <a:buNone/>
+            </a:pPr>
+            <a:r>
+              <a:rPr lang="en-US" sz="1500" b="1" dirty="0">
+                <a:solidFill>
+                  <a:srgbClr val="B8772E"/>
+                </a:solidFill>
+                <a:latin typeface="Yu Gothic" pitchFamily="34" charset="0"/>
+                <a:ea typeface="Yu Gothic" pitchFamily="34" charset="-122"/>
+                <a:cs typeface="Yu Gothic" pitchFamily="34" charset="-120"/>
+              </a:rPr>
+              <a:t>02. Place</a:t>
+            </a:r>
+            <a:endParaRPr lang="en-US" sz="1500" dirty="0"/>
+          </a:p>
+        </p:txBody>
+      </p:sp>
+      <p:sp>
+        <p:nvSpPr>
+          <p:cNvPr id="13" name="Text 11"/>
+          <p:cNvSpPr/>
+          <p:nvPr/>
+        </p:nvSpPr>
+        <p:spPr>
+          <a:xfrm>
+            <a:off x="4740554" y="2807208"/>
+            <a:ext cx="2710586" cy="777240"/>
+          </a:xfrm>
+          <a:prstGeom prst="rect">
+            <a:avLst/>
+          </a:prstGeom>
+          <a:noFill/>
+          <a:ln/>
+        </p:spPr>
+        <p:txBody>
+          <a:bodyPr wrap="square" lIns="0" tIns="0" rIns="0" bIns="0" rtlCol="0" anchor="t"/>
+          <a:lstStyle/>
+          <a:p>
+            <a:pPr indent="0" marL="0">
+              <a:lnSpc>
+                <a:spcPct val="115000"/>
+              </a:lnSpc>
+              <a:buNone/>
+            </a:pPr>
+            <a:r>
+              <a:rPr lang="en-US" sz="1800" b="1" dirty="0">
+                <a:solidFill>
+                  <a:srgbClr val="222222"/>
+                </a:solidFill>
+                <a:latin typeface="Yu Gothic" pitchFamily="34" charset="0"/>
+                <a:ea typeface="Yu Gothic" pitchFamily="34" charset="-122"/>
+                <a:cs typeface="Yu Gothic" pitchFamily="34" charset="-120"/>
+              </a:rPr>
+              <a:t>つくる人が、集まる場所</a:t>
+            </a:r>
+            <a:endParaRPr lang="en-US" sz="1800" dirty="0"/>
+          </a:p>
+        </p:txBody>
+      </p:sp>
+      <p:sp>
+        <p:nvSpPr>
+          <p:cNvPr id="14" name="Text 12"/>
+          <p:cNvSpPr/>
+          <p:nvPr/>
+        </p:nvSpPr>
+        <p:spPr>
+          <a:xfrm>
+            <a:off x="4740554" y="3657600"/>
+            <a:ext cx="2710586" cy="2103120"/>
+          </a:xfrm>
+          <a:prstGeom prst="rect">
+            <a:avLst/>
+          </a:prstGeom>
+          <a:noFill/>
+          <a:ln/>
+        </p:spPr>
+        <p:txBody>
+          <a:bodyPr wrap="square" lIns="0" tIns="0" rIns="0" bIns="0" rtlCol="0" anchor="t"/>
+          <a:lstStyle/>
+          <a:p>
+            <a:pPr algn="l" indent="0" marL="0">
+              <a:lnSpc>
+                <a:spcPct val="132000"/>
+              </a:lnSpc>
+              <a:buNone/>
+            </a:pPr>
+            <a:r>
+              <a:rPr lang="en-US" sz="1150" dirty="0">
+                <a:solidFill>
+                  <a:srgbClr val="707070"/>
+                </a:solidFill>
+                <a:latin typeface="Yu Gothic" pitchFamily="34" charset="0"/>
+                <a:ea typeface="Yu Gothic" pitchFamily="34" charset="-122"/>
+                <a:cs typeface="Yu Gothic" pitchFamily="34" charset="-120"/>
+              </a:rPr>
+              <a:t>全国に広がるShopBotオーナーの拠点は、単なる加工施設ではない。クリエイターが集い、技術を共有し、ものづくりの文化を育てる場になっている。VUILDはそのネットワークを活性化し、全国的なものづくりの動きへとつなげていく。</a:t>
+            </a:r>
+            <a:endParaRPr lang="en-US" sz="1150" dirty="0"/>
+          </a:p>
+        </p:txBody>
+      </p:sp>
+      <p:sp>
+        <p:nvSpPr>
+          <p:cNvPr id="15" name="Shape 13"/>
+          <p:cNvSpPr/>
+          <p:nvPr/>
+        </p:nvSpPr>
+        <p:spPr>
+          <a:xfrm>
+            <a:off x="8091221" y="2057400"/>
+            <a:ext cx="3259226" cy="3840480"/>
+          </a:xfrm>
+          <a:prstGeom prst="rect">
+            <a:avLst/>
+          </a:prstGeom>
+          <a:solidFill>
+            <a:srgbClr val="FFFFFF"/>
+          </a:solidFill>
+          <a:ln w="12700">
+            <a:solidFill>
+              <a:srgbClr val="E4E1DC"/>
+            </a:solidFill>
+            <a:prstDash val="solid"/>
+          </a:ln>
+        </p:spPr>
+      </p:sp>
+      <p:sp>
+        <p:nvSpPr>
+          <p:cNvPr id="16" name="Shape 14"/>
+          <p:cNvSpPr/>
+          <p:nvPr/>
+        </p:nvSpPr>
+        <p:spPr>
+          <a:xfrm>
+            <a:off x="8091221" y="2057400"/>
+            <a:ext cx="3259226" cy="82296"/>
+          </a:xfrm>
+          <a:prstGeom prst="rect">
+            <a:avLst/>
+          </a:prstGeom>
+          <a:solidFill>
+            <a:srgbClr val="B8772E"/>
+          </a:solidFill>
+          <a:ln/>
+        </p:spPr>
+      </p:sp>
+      <p:sp>
+        <p:nvSpPr>
+          <p:cNvPr id="17" name="Text 15"/>
+          <p:cNvSpPr/>
+          <p:nvPr/>
+        </p:nvSpPr>
+        <p:spPr>
+          <a:xfrm>
+            <a:off x="8365541" y="2350008"/>
+            <a:ext cx="2710586" cy="365760"/>
+          </a:xfrm>
+          <a:prstGeom prst="rect">
+            <a:avLst/>
+          </a:prstGeom>
+          <a:noFill/>
+          <a:ln/>
+        </p:spPr>
+        <p:txBody>
+          <a:bodyPr wrap="square" lIns="0" tIns="0" rIns="0" bIns="0" rtlCol="0" anchor="t"/>
+          <a:lstStyle/>
+          <a:p>
+            <a:pPr indent="0" marL="0">
+              <a:buNone/>
+            </a:pPr>
+            <a:r>
+              <a:rPr lang="en-US" sz="1500" b="1" dirty="0">
+                <a:solidFill>
+                  <a:srgbClr val="B8772E"/>
+                </a:solidFill>
+                <a:latin typeface="Yu Gothic" pitchFamily="34" charset="0"/>
+                <a:ea typeface="Yu Gothic" pitchFamily="34" charset="-122"/>
+                <a:cs typeface="Yu Gothic" pitchFamily="34" charset="-120"/>
+              </a:rPr>
+              <a:t>03. Knowledge</a:t>
+            </a:r>
+            <a:endParaRPr lang="en-US" sz="1500" dirty="0"/>
+          </a:p>
+        </p:txBody>
+      </p:sp>
+      <p:sp>
+        <p:nvSpPr>
+          <p:cNvPr id="18" name="Text 16"/>
+          <p:cNvSpPr/>
+          <p:nvPr/>
+        </p:nvSpPr>
+        <p:spPr>
+          <a:xfrm>
+            <a:off x="8365541" y="2807208"/>
+            <a:ext cx="2710586" cy="777240"/>
+          </a:xfrm>
+          <a:prstGeom prst="rect">
+            <a:avLst/>
+          </a:prstGeom>
+          <a:noFill/>
+          <a:ln/>
+        </p:spPr>
+        <p:txBody>
+          <a:bodyPr wrap="square" lIns="0" tIns="0" rIns="0" bIns="0" rtlCol="0" anchor="t"/>
+          <a:lstStyle/>
+          <a:p>
+            <a:pPr indent="0" marL="0">
+              <a:lnSpc>
+                <a:spcPct val="115000"/>
+              </a:lnSpc>
+              <a:buNone/>
+            </a:pPr>
+            <a:r>
+              <a:rPr lang="en-US" sz="1800" b="1" dirty="0">
+                <a:solidFill>
+                  <a:srgbClr val="222222"/>
+                </a:solidFill>
+                <a:latin typeface="Yu Gothic" pitchFamily="34" charset="0"/>
+                <a:ea typeface="Yu Gothic" pitchFamily="34" charset="-122"/>
+                <a:cs typeface="Yu Gothic" pitchFamily="34" charset="-120"/>
+              </a:rPr>
+              <a:t>つくり方を、受け継いでいく</a:t>
+            </a:r>
+            <a:endParaRPr lang="en-US" sz="1800" dirty="0"/>
+          </a:p>
+        </p:txBody>
+      </p:sp>
+      <p:sp>
+        <p:nvSpPr>
+          <p:cNvPr id="19" name="Text 17"/>
+          <p:cNvSpPr/>
+          <p:nvPr/>
+        </p:nvSpPr>
+        <p:spPr>
+          <a:xfrm>
+            <a:off x="8365541" y="3657600"/>
+            <a:ext cx="2710586" cy="2103120"/>
+          </a:xfrm>
+          <a:prstGeom prst="rect">
+            <a:avLst/>
+          </a:prstGeom>
+          <a:noFill/>
+          <a:ln/>
+        </p:spPr>
+        <p:txBody>
+          <a:bodyPr wrap="square" lIns="0" tIns="0" rIns="0" bIns="0" rtlCol="0" anchor="t"/>
+          <a:lstStyle/>
+          <a:p>
+            <a:pPr algn="l" indent="0" marL="0">
+              <a:lnSpc>
+                <a:spcPct val="132000"/>
+              </a:lnSpc>
+              <a:buNone/>
+            </a:pPr>
+            <a:r>
+              <a:rPr lang="en-US" sz="1150" dirty="0">
+                <a:solidFill>
+                  <a:srgbClr val="707070"/>
+                </a:solidFill>
+                <a:latin typeface="Yu Gothic" pitchFamily="34" charset="0"/>
+                <a:ea typeface="Yu Gothic" pitchFamily="34" charset="-122"/>
+                <a:cs typeface="Yu Gothic" pitchFamily="34" charset="-120"/>
+              </a:rPr>
+              <a:t>機械の使い方だけでなく、デザインの思想ごと伝える。ShopBot導入後の伴走支援から、学校法人向けプログラム、地域に入り込んだ人材育成まで。ものづくりの担い手を、地域の中から増やしていく。</a:t>
+            </a:r>
+            <a:endParaRPr lang="en-US" sz="1150" dirty="0"/>
+          </a:p>
+        </p:txBody>
+      </p:sp>
+      <p:sp>
+        <p:nvSpPr>
+          <p:cNvPr id="20" name="Text 18"/>
+          <p:cNvSpPr/>
+          <p:nvPr/>
+        </p:nvSpPr>
+        <p:spPr>
+          <a:xfrm>
+            <a:off x="841248" y="6400800"/>
+            <a:ext cx="7315200" cy="274320"/>
+          </a:xfrm>
+          <a:prstGeom prst="rect">
+            <a:avLst/>
+          </a:prstGeom>
+          <a:noFill/>
+          <a:ln/>
+        </p:spPr>
+        <p:txBody>
+          <a:bodyPr wrap="square" lIns="0" tIns="0" rIns="0" bIns="0" rtlCol="0" anchor="t"/>
+          <a:lstStyle/>
+          <a:p>
+            <a:pPr indent="0" marL="0">
+              <a:buNone/>
+            </a:pPr>
+            <a:r>
+              <a:rPr lang="en-US" sz="900" dirty="0">
+                <a:solidFill>
+                  <a:srgbClr val="A8A8A8"/>
+                </a:solidFill>
+                <a:latin typeface="Yu Gothic" pitchFamily="34" charset="0"/>
+                <a:ea typeface="Yu Gothic" pitchFamily="34" charset="-122"/>
+                <a:cs typeface="Yu Gothic" pitchFamily="34" charset="-120"/>
+              </a:rPr>
+              <a:t>Incubation Team OKR ・ リーダー定例 2026-06-28</a:t>
+            </a:r>
+            <a:endParaRPr lang="en-US" sz="900" dirty="0"/>
+          </a:p>
+        </p:txBody>
+      </p:sp>
+      <p:sp>
+        <p:nvSpPr>
+          <p:cNvPr id="21" name="Text 19"/>
+          <p:cNvSpPr/>
+          <p:nvPr/>
+        </p:nvSpPr>
+        <p:spPr>
+          <a:xfrm>
+            <a:off x="10436047" y="6400800"/>
+            <a:ext cx="914400" cy="274320"/>
+          </a:xfrm>
+          <a:prstGeom prst="rect">
+            <a:avLst/>
+          </a:prstGeom>
+          <a:noFill/>
+          <a:ln/>
+        </p:spPr>
+        <p:txBody>
+          <a:bodyPr wrap="square" lIns="0" tIns="0" rIns="0" bIns="0" rtlCol="0" anchor="t"/>
+          <a:lstStyle/>
+          <a:p>
+            <a:pPr algn="r" indent="0" marL="0">
+              <a:buNone/>
+            </a:pPr>
+            <a:r>
+              <a:rPr lang="en-US" sz="900" dirty="0">
+                <a:solidFill>
+                  <a:srgbClr val="A8A8A8"/>
+                </a:solidFill>
+                <a:latin typeface="Yu Gothic" pitchFamily="34" charset="0"/>
+                <a:ea typeface="Yu Gothic" pitchFamily="34" charset="-122"/>
+                <a:cs typeface="Yu Gothic" pitchFamily="34" charset="-120"/>
+              </a:rPr>
+              <a:t>12</a:t>
+            </a:r>
+            <a:endParaRPr lang="en-US" sz="900" dirty="0"/>
+          </a:p>
+        </p:txBody>
+      </p:sp>
+    </p:spTree>
+  </p:cSld>
+  <p:clrMapOvr>
+    <a:masterClrMapping/>
+  </p:clrMapOvr>
+</p:sld>
+</file>
+
+<file path=ppt/slides/slide13.xml><?xml version="1.0" encoding="utf-8"?>
+<p:sld xmlns:a="http://schemas.openxmlformats.org/drawingml/2006/main" xmlns:r="http://schemas.openxmlformats.org/officeDocument/2006/relationships" xmlns:p="http://schemas.openxmlformats.org/presentationml/2006/main">
+  <p:cSld name="Slide 13">
+    <p:bg>
+      <p:bgPr>
+        <a:solidFill>
+          <a:srgbClr val="FDFCFA"/>
+        </a:solidFill>
+      </p:bgPr>
+    </p:bg>
+    <p:spTree>
+      <p:nvGrpSpPr>
+        <p:cNvPr id="1" name=""/>
+        <p:cNvGrpSpPr/>
+        <p:nvPr/>
+      </p:nvGrpSpPr>
+      <p:grpSpPr>
+        <a:xfrm>
+          <a:off x="0" y="0"/>
+          <a:ext cx="0" cy="0"/>
+          <a:chOff x="0" y="0"/>
+          <a:chExt cx="0" cy="0"/>
+        </a:xfrm>
+      </p:grpSpPr>
+      <p:sp>
+        <p:nvSpPr>
+          <p:cNvPr id="2" name="Shape 0"/>
+          <p:cNvSpPr/>
+          <p:nvPr/>
+        </p:nvSpPr>
+        <p:spPr>
+          <a:xfrm>
+            <a:off x="841248" y="566928"/>
+            <a:ext cx="384048" cy="77724"/>
+          </a:xfrm>
+          <a:prstGeom prst="rect">
+            <a:avLst/>
+          </a:prstGeom>
+          <a:solidFill>
+            <a:srgbClr val="B8772E"/>
+          </a:solidFill>
+          <a:ln/>
+        </p:spPr>
+      </p:sp>
+      <p:sp>
+        <p:nvSpPr>
+          <p:cNvPr id="3" name="Text 1"/>
+          <p:cNvSpPr/>
+          <p:nvPr/>
+        </p:nvSpPr>
+        <p:spPr>
+          <a:xfrm>
+            <a:off x="841248" y="731520"/>
+            <a:ext cx="10509199" cy="365760"/>
+          </a:xfrm>
+          <a:prstGeom prst="rect">
+            <a:avLst/>
+          </a:prstGeom>
+          <a:noFill/>
+          <a:ln/>
+        </p:spPr>
+        <p:txBody>
+          <a:bodyPr wrap="square" lIns="0" tIns="0" rIns="0" bIns="0" rtlCol="0" anchor="t"/>
+          <a:lstStyle/>
+          <a:p>
+            <a:pPr indent="0" marL="0">
+              <a:buNone/>
+            </a:pPr>
+            <a:r>
+              <a:rPr lang="en-US" sz="1350" b="1" dirty="0">
+                <a:solidFill>
+                  <a:srgbClr val="B8772E"/>
+                </a:solidFill>
+                <a:latin typeface="Yu Gothic" pitchFamily="34" charset="0"/>
+                <a:ea typeface="Yu Gothic" pitchFamily="34" charset="-122"/>
+                <a:cs typeface="Yu Gothic" pitchFamily="34" charset="-120"/>
+              </a:rPr>
+              <a:t>What we do ｜ Solution</a:t>
+            </a:r>
+            <a:endParaRPr lang="en-US" sz="1350" dirty="0"/>
+          </a:p>
+        </p:txBody>
+      </p:sp>
+      <p:sp>
+        <p:nvSpPr>
+          <p:cNvPr id="4" name="Text 2"/>
+          <p:cNvSpPr/>
+          <p:nvPr/>
+        </p:nvSpPr>
+        <p:spPr>
+          <a:xfrm>
+            <a:off x="841248" y="1078992"/>
+            <a:ext cx="10509199" cy="868680"/>
+          </a:xfrm>
+          <a:prstGeom prst="rect">
+            <a:avLst/>
+          </a:prstGeom>
+          <a:noFill/>
+          <a:ln/>
+        </p:spPr>
+        <p:txBody>
+          <a:bodyPr wrap="square" lIns="0" tIns="0" rIns="0" bIns="0" rtlCol="0" anchor="t"/>
+          <a:lstStyle/>
+          <a:p>
+            <a:pPr indent="0" marL="0">
+              <a:lnSpc>
+                <a:spcPct val="105000"/>
+              </a:lnSpc>
+              <a:buNone/>
+            </a:pPr>
+            <a:r>
+              <a:rPr lang="en-US" sz="3000" b="1" dirty="0">
+                <a:solidFill>
+                  <a:srgbClr val="222222"/>
+                </a:solidFill>
+                <a:latin typeface="Yu Gothic" pitchFamily="34" charset="0"/>
+                <a:ea typeface="Yu Gothic" pitchFamily="34" charset="-122"/>
+                <a:cs typeface="Yu Gothic" pitchFamily="34" charset="-120"/>
+              </a:rPr>
+              <a:t>提供するソリューション</a:t>
+            </a:r>
+            <a:endParaRPr lang="en-US" sz="3000" dirty="0"/>
+          </a:p>
+        </p:txBody>
+      </p:sp>
+      <p:sp>
+        <p:nvSpPr>
+          <p:cNvPr id="5" name="Shape 3"/>
+          <p:cNvSpPr/>
+          <p:nvPr/>
+        </p:nvSpPr>
+        <p:spPr>
+          <a:xfrm>
+            <a:off x="841248" y="2286000"/>
+            <a:ext cx="3259226" cy="3200400"/>
+          </a:xfrm>
+          <a:prstGeom prst="rect">
+            <a:avLst/>
+          </a:prstGeom>
+          <a:solidFill>
+            <a:srgbClr val="FFFFFF"/>
+          </a:solidFill>
+          <a:ln w="12700">
+            <a:solidFill>
+              <a:srgbClr val="E4E1DC"/>
+            </a:solidFill>
+            <a:prstDash val="solid"/>
+          </a:ln>
+        </p:spPr>
+      </p:sp>
+      <p:sp>
+        <p:nvSpPr>
+          <p:cNvPr id="6" name="Shape 4"/>
+          <p:cNvSpPr/>
+          <p:nvPr/>
+        </p:nvSpPr>
+        <p:spPr>
+          <a:xfrm>
+            <a:off x="841248" y="2286000"/>
+            <a:ext cx="73152" cy="3200400"/>
+          </a:xfrm>
+          <a:prstGeom prst="rect">
+            <a:avLst/>
+          </a:prstGeom>
+          <a:solidFill>
+            <a:srgbClr val="B8772E"/>
+          </a:solidFill>
+          <a:ln/>
+        </p:spPr>
+      </p:sp>
+      <p:sp>
+        <p:nvSpPr>
+          <p:cNvPr id="7" name="Text 5"/>
+          <p:cNvSpPr/>
+          <p:nvPr/>
+        </p:nvSpPr>
+        <p:spPr>
+          <a:xfrm>
+            <a:off x="1133856" y="2560320"/>
+            <a:ext cx="2710586" cy="457200"/>
+          </a:xfrm>
+          <a:prstGeom prst="rect">
+            <a:avLst/>
+          </a:prstGeom>
+          <a:noFill/>
+          <a:ln/>
+        </p:spPr>
+        <p:txBody>
+          <a:bodyPr wrap="square" lIns="0" tIns="0" rIns="0" bIns="0" rtlCol="0" anchor="t"/>
+          <a:lstStyle/>
+          <a:p>
+            <a:pPr indent="0" marL="0">
+              <a:buNone/>
+            </a:pPr>
+            <a:r>
+              <a:rPr lang="en-US" sz="1800" b="1" dirty="0">
+                <a:solidFill>
+                  <a:srgbClr val="222222"/>
+                </a:solidFill>
+                <a:latin typeface="Yu Gothic" pitchFamily="34" charset="0"/>
+                <a:ea typeface="Yu Gothic" pitchFamily="34" charset="-122"/>
+                <a:cs typeface="Yu Gothic" pitchFamily="34" charset="-120"/>
+              </a:rPr>
+              <a:t>ShopBot®</a:t>
+            </a:r>
+            <a:endParaRPr lang="en-US" sz="1800" dirty="0"/>
+          </a:p>
+        </p:txBody>
+      </p:sp>
+      <p:sp>
+        <p:nvSpPr>
+          <p:cNvPr id="8" name="Text 6"/>
+          <p:cNvSpPr/>
+          <p:nvPr/>
+        </p:nvSpPr>
+        <p:spPr>
+          <a:xfrm>
+            <a:off x="1133856" y="3154680"/>
+            <a:ext cx="2692298" cy="1737360"/>
+          </a:xfrm>
+          <a:prstGeom prst="rect">
+            <a:avLst/>
+          </a:prstGeom>
+          <a:noFill/>
+          <a:ln/>
+        </p:spPr>
+        <p:txBody>
+          <a:bodyPr wrap="square" lIns="0" tIns="0" rIns="0" bIns="0" rtlCol="0" anchor="t"/>
+          <a:lstStyle/>
+          <a:p>
+            <a:pPr indent="0" marL="0">
+              <a:lnSpc>
+                <a:spcPct val="132000"/>
+              </a:lnSpc>
+              <a:buNone/>
+            </a:pPr>
+            <a:r>
+              <a:rPr lang="en-US" sz="1250" dirty="0">
+                <a:solidFill>
+                  <a:srgbClr val="707070"/>
+                </a:solidFill>
+                <a:latin typeface="Yu Gothic" pitchFamily="34" charset="0"/>
+                <a:ea typeface="Yu Gothic" pitchFamily="34" charset="-122"/>
+                <a:cs typeface="Yu Gothic" pitchFamily="34" charset="-120"/>
+              </a:rPr>
+              <a:t>木材を自在に加工できるCNCルーター。全国280拠点に広がるオーナーネットワークが、ものづくりの現場を支えている。</a:t>
+            </a:r>
+            <a:endParaRPr lang="en-US" sz="1250" dirty="0"/>
+          </a:p>
+        </p:txBody>
+      </p:sp>
+      <p:sp>
+        <p:nvSpPr>
+          <p:cNvPr id="9" name="Shape 7"/>
+          <p:cNvSpPr/>
+          <p:nvPr/>
+        </p:nvSpPr>
+        <p:spPr>
+          <a:xfrm>
+            <a:off x="1133856" y="4919472"/>
+            <a:ext cx="2692298" cy="10973"/>
+          </a:xfrm>
+          <a:prstGeom prst="rect">
+            <a:avLst/>
+          </a:prstGeom>
+          <a:solidFill>
+            <a:srgbClr val="E4E1DC"/>
+          </a:solidFill>
+          <a:ln/>
+        </p:spPr>
+      </p:sp>
+      <p:sp>
+        <p:nvSpPr>
+          <p:cNvPr id="10" name="Text 8"/>
+          <p:cNvSpPr/>
+          <p:nvPr/>
+        </p:nvSpPr>
+        <p:spPr>
+          <a:xfrm>
+            <a:off x="1133856" y="5029200"/>
+            <a:ext cx="2710586" cy="320040"/>
+          </a:xfrm>
+          <a:prstGeom prst="rect">
+            <a:avLst/>
+          </a:prstGeom>
+          <a:noFill/>
+          <a:ln/>
+        </p:spPr>
+        <p:txBody>
+          <a:bodyPr wrap="square" lIns="0" tIns="0" rIns="0" bIns="0" rtlCol="0" anchor="t"/>
+          <a:lstStyle/>
+          <a:p>
+            <a:pPr indent="0" marL="0">
+              <a:buNone/>
+            </a:pPr>
+            <a:r>
+              <a:rPr lang="en-US" sz="1200" b="1" dirty="0">
+                <a:solidFill>
+                  <a:srgbClr val="B8772E"/>
+                </a:solidFill>
+                <a:latin typeface="Yu Gothic" pitchFamily="34" charset="0"/>
+                <a:ea typeface="Yu Gothic" pitchFamily="34" charset="-122"/>
+                <a:cs typeface="Yu Gothic" pitchFamily="34" charset="-120"/>
+              </a:rPr>
+              <a:t>→ ShopBot</a:t>
+            </a:r>
+            <a:endParaRPr lang="en-US" sz="1200" dirty="0"/>
+          </a:p>
+        </p:txBody>
+      </p:sp>
+      <p:sp>
+        <p:nvSpPr>
+          <p:cNvPr id="11" name="Shape 9"/>
+          <p:cNvSpPr/>
+          <p:nvPr/>
+        </p:nvSpPr>
+        <p:spPr>
+          <a:xfrm>
+            <a:off x="4466234" y="2286000"/>
+            <a:ext cx="3259226" cy="3200400"/>
+          </a:xfrm>
+          <a:prstGeom prst="rect">
+            <a:avLst/>
+          </a:prstGeom>
+          <a:solidFill>
+            <a:srgbClr val="FFFFFF"/>
+          </a:solidFill>
+          <a:ln w="12700">
+            <a:solidFill>
+              <a:srgbClr val="E4E1DC"/>
+            </a:solidFill>
+            <a:prstDash val="solid"/>
+          </a:ln>
+        </p:spPr>
+      </p:sp>
+      <p:sp>
+        <p:nvSpPr>
+          <p:cNvPr id="12" name="Shape 10"/>
+          <p:cNvSpPr/>
+          <p:nvPr/>
+        </p:nvSpPr>
+        <p:spPr>
+          <a:xfrm>
+            <a:off x="4466234" y="2286000"/>
+            <a:ext cx="73152" cy="3200400"/>
+          </a:xfrm>
+          <a:prstGeom prst="rect">
+            <a:avLst/>
+          </a:prstGeom>
+          <a:solidFill>
+            <a:srgbClr val="B8772E"/>
+          </a:solidFill>
+          <a:ln/>
+        </p:spPr>
+      </p:sp>
+      <p:sp>
+        <p:nvSpPr>
+          <p:cNvPr id="13" name="Text 11"/>
+          <p:cNvSpPr/>
+          <p:nvPr/>
+        </p:nvSpPr>
+        <p:spPr>
+          <a:xfrm>
+            <a:off x="4758842" y="2560320"/>
+            <a:ext cx="2710586" cy="457200"/>
+          </a:xfrm>
+          <a:prstGeom prst="rect">
+            <a:avLst/>
+          </a:prstGeom>
+          <a:noFill/>
+          <a:ln/>
+        </p:spPr>
+        <p:txBody>
+          <a:bodyPr wrap="square" lIns="0" tIns="0" rIns="0" bIns="0" rtlCol="0" anchor="t"/>
+          <a:lstStyle/>
+          <a:p>
+            <a:pPr indent="0" marL="0">
+              <a:buNone/>
+            </a:pPr>
+            <a:r>
+              <a:rPr lang="en-US" sz="1800" b="1" dirty="0">
+                <a:solidFill>
+                  <a:srgbClr val="222222"/>
+                </a:solidFill>
+                <a:latin typeface="Yu Gothic" pitchFamily="34" charset="0"/>
+                <a:ea typeface="Yu Gothic" pitchFamily="34" charset="-122"/>
+                <a:cs typeface="Yu Gothic" pitchFamily="34" charset="-120"/>
+              </a:rPr>
+              <a:t>教育プログラム</a:t>
+            </a:r>
+            <a:endParaRPr lang="en-US" sz="1800" dirty="0"/>
+          </a:p>
+        </p:txBody>
+      </p:sp>
+      <p:sp>
+        <p:nvSpPr>
+          <p:cNvPr id="14" name="Text 12"/>
+          <p:cNvSpPr/>
+          <p:nvPr/>
+        </p:nvSpPr>
+        <p:spPr>
+          <a:xfrm>
+            <a:off x="4758842" y="3154680"/>
+            <a:ext cx="2692298" cy="1737360"/>
+          </a:xfrm>
+          <a:prstGeom prst="rect">
+            <a:avLst/>
+          </a:prstGeom>
+          <a:noFill/>
+          <a:ln/>
+        </p:spPr>
+        <p:txBody>
+          <a:bodyPr wrap="square" lIns="0" tIns="0" rIns="0" bIns="0" rtlCol="0" anchor="t"/>
+          <a:lstStyle/>
+          <a:p>
+            <a:pPr indent="0" marL="0">
+              <a:lnSpc>
+                <a:spcPct val="132000"/>
+              </a:lnSpc>
+              <a:buNone/>
+            </a:pPr>
+            <a:r>
+              <a:rPr lang="en-US" sz="1250" dirty="0">
+                <a:solidFill>
+                  <a:srgbClr val="707070"/>
+                </a:solidFill>
+                <a:latin typeface="Yu Gothic" pitchFamily="34" charset="0"/>
+                <a:ea typeface="Yu Gothic" pitchFamily="34" charset="-122"/>
+                <a:cs typeface="Yu Gothic" pitchFamily="34" charset="-120"/>
+              </a:rPr>
+              <a:t>デザインからものづくりまでの智を獲得する教育プログラムの提供。</a:t>
+            </a:r>
+            <a:endParaRPr lang="en-US" sz="1250" dirty="0"/>
+          </a:p>
+        </p:txBody>
+      </p:sp>
+      <p:sp>
+        <p:nvSpPr>
+          <p:cNvPr id="15" name="Shape 13"/>
+          <p:cNvSpPr/>
+          <p:nvPr/>
+        </p:nvSpPr>
+        <p:spPr>
+          <a:xfrm>
+            <a:off x="4758842" y="4919472"/>
+            <a:ext cx="2692298" cy="10973"/>
+          </a:xfrm>
+          <a:prstGeom prst="rect">
+            <a:avLst/>
+          </a:prstGeom>
+          <a:solidFill>
+            <a:srgbClr val="E4E1DC"/>
+          </a:solidFill>
+          <a:ln/>
+        </p:spPr>
+      </p:sp>
+      <p:sp>
+        <p:nvSpPr>
+          <p:cNvPr id="16" name="Text 14"/>
+          <p:cNvSpPr/>
+          <p:nvPr/>
+        </p:nvSpPr>
+        <p:spPr>
+          <a:xfrm>
+            <a:off x="4758842" y="5029200"/>
+            <a:ext cx="2710586" cy="320040"/>
+          </a:xfrm>
+          <a:prstGeom prst="rect">
+            <a:avLst/>
+          </a:prstGeom>
+          <a:noFill/>
+          <a:ln/>
+        </p:spPr>
+        <p:txBody>
+          <a:bodyPr wrap="square" lIns="0" tIns="0" rIns="0" bIns="0" rtlCol="0" anchor="t"/>
+          <a:lstStyle/>
+          <a:p>
+            <a:pPr indent="0" marL="0">
+              <a:buNone/>
+            </a:pPr>
+            <a:r>
+              <a:rPr lang="en-US" sz="1200" b="1" dirty="0">
+                <a:solidFill>
+                  <a:srgbClr val="B8772E"/>
+                </a:solidFill>
+                <a:latin typeface="Yu Gothic" pitchFamily="34" charset="0"/>
+                <a:ea typeface="Yu Gothic" pitchFamily="34" charset="-122"/>
+                <a:cs typeface="Yu Gothic" pitchFamily="34" charset="-120"/>
+              </a:rPr>
+              <a:t>→ CMSで記事をつくる</a:t>
+            </a:r>
+            <a:endParaRPr lang="en-US" sz="1200" dirty="0"/>
+          </a:p>
+        </p:txBody>
+      </p:sp>
+      <p:sp>
+        <p:nvSpPr>
+          <p:cNvPr id="17" name="Shape 15"/>
+          <p:cNvSpPr/>
+          <p:nvPr/>
+        </p:nvSpPr>
+        <p:spPr>
+          <a:xfrm>
+            <a:off x="8091221" y="2286000"/>
+            <a:ext cx="3259226" cy="3200400"/>
+          </a:xfrm>
+          <a:prstGeom prst="rect">
+            <a:avLst/>
+          </a:prstGeom>
+          <a:solidFill>
+            <a:srgbClr val="FFFFFF"/>
+          </a:solidFill>
+          <a:ln w="12700">
+            <a:solidFill>
+              <a:srgbClr val="E4E1DC"/>
+            </a:solidFill>
+            <a:prstDash val="solid"/>
+          </a:ln>
+        </p:spPr>
+      </p:sp>
+      <p:sp>
+        <p:nvSpPr>
+          <p:cNvPr id="18" name="Shape 16"/>
+          <p:cNvSpPr/>
+          <p:nvPr/>
+        </p:nvSpPr>
+        <p:spPr>
+          <a:xfrm>
+            <a:off x="8091221" y="2286000"/>
+            <a:ext cx="73152" cy="3200400"/>
+          </a:xfrm>
+          <a:prstGeom prst="rect">
+            <a:avLst/>
+          </a:prstGeom>
+          <a:solidFill>
+            <a:srgbClr val="B8772E"/>
+          </a:solidFill>
+          <a:ln/>
+        </p:spPr>
+      </p:sp>
+      <p:sp>
+        <p:nvSpPr>
+          <p:cNvPr id="19" name="Text 17"/>
+          <p:cNvSpPr/>
+          <p:nvPr/>
+        </p:nvSpPr>
+        <p:spPr>
+          <a:xfrm>
+            <a:off x="8383829" y="2560320"/>
+            <a:ext cx="2710586" cy="457200"/>
+          </a:xfrm>
+          <a:prstGeom prst="rect">
+            <a:avLst/>
+          </a:prstGeom>
+          <a:noFill/>
+          <a:ln/>
+        </p:spPr>
+        <p:txBody>
+          <a:bodyPr wrap="square" lIns="0" tIns="0" rIns="0" bIns="0" rtlCol="0" anchor="t"/>
+          <a:lstStyle/>
+          <a:p>
+            <a:pPr indent="0" marL="0">
+              <a:buNone/>
+            </a:pPr>
+            <a:r>
+              <a:rPr lang="en-US" sz="1800" b="1" dirty="0">
+                <a:solidFill>
+                  <a:srgbClr val="222222"/>
+                </a:solidFill>
+                <a:latin typeface="Yu Gothic" pitchFamily="34" charset="0"/>
+                <a:ea typeface="Yu Gothic" pitchFamily="34" charset="-122"/>
+                <a:cs typeface="Yu Gothic" pitchFamily="34" charset="-120"/>
+              </a:rPr>
+              <a:t>ものづくり支援アプリ</a:t>
+            </a:r>
+            <a:endParaRPr lang="en-US" sz="1800" dirty="0"/>
+          </a:p>
+        </p:txBody>
+      </p:sp>
+      <p:sp>
+        <p:nvSpPr>
+          <p:cNvPr id="20" name="Text 18"/>
+          <p:cNvSpPr/>
+          <p:nvPr/>
+        </p:nvSpPr>
+        <p:spPr>
+          <a:xfrm>
+            <a:off x="8383829" y="3154680"/>
+            <a:ext cx="2692298" cy="1737360"/>
+          </a:xfrm>
+          <a:prstGeom prst="rect">
+            <a:avLst/>
+          </a:prstGeom>
+          <a:noFill/>
+          <a:ln/>
+        </p:spPr>
+        <p:txBody>
+          <a:bodyPr wrap="square" lIns="0" tIns="0" rIns="0" bIns="0" rtlCol="0" anchor="t"/>
+          <a:lstStyle/>
+          <a:p>
+            <a:pPr indent="0" marL="0">
+              <a:lnSpc>
+                <a:spcPct val="132000"/>
+              </a:lnSpc>
+              <a:spcAft>
+                <a:spcPts val="600"/>
+              </a:spcAft>
+              <a:buNone/>
+            </a:pPr>
+            <a:r>
+              <a:rPr lang="en-US" sz="1250" strike="sngStrike" dirty="0">
+                <a:solidFill>
+                  <a:srgbClr val="A8A8A8"/>
+                </a:solidFill>
+                <a:latin typeface="Yu Gothic" pitchFamily="34" charset="0"/>
+                <a:ea typeface="Yu Gothic" pitchFamily="34" charset="-122"/>
+                <a:cs typeface="Yu Gothic" pitchFamily="34" charset="-120"/>
+              </a:rPr>
+              <a:t>デザインから加工データまでを一つの流れでつなぐ、設計製作補助ツール。データベース・CAD・CAMの3つにアクセスできる。</a:t>
+            </a:r>
+            <a:endParaRPr lang="en-US" sz="1250" dirty="0"/>
+          </a:p>
+          <a:p>
+            <a:pPr indent="0" marL="0">
+              <a:buNone/>
+            </a:pPr>
+            <a:r>
+              <a:rPr lang="en-US" sz="1100" b="1" dirty="0">
+                <a:solidFill>
+                  <a:srgbClr val="B8772E"/>
+                </a:solidFill>
+                <a:latin typeface="Yu Gothic" pitchFamily="34" charset="0"/>
+                <a:ea typeface="Yu Gothic" pitchFamily="34" charset="-122"/>
+                <a:cs typeface="Yu Gothic" pitchFamily="34" charset="-120"/>
+              </a:rPr>
+              <a:t>※ 説明文は再検討中</a:t>
+            </a:r>
+            <a:endParaRPr lang="en-US" sz="1250" dirty="0"/>
+          </a:p>
+        </p:txBody>
+      </p:sp>
+      <p:sp>
+        <p:nvSpPr>
+          <p:cNvPr id="21" name="Shape 19"/>
+          <p:cNvSpPr/>
+          <p:nvPr/>
+        </p:nvSpPr>
+        <p:spPr>
+          <a:xfrm>
+            <a:off x="8383829" y="4919472"/>
+            <a:ext cx="2692298" cy="10973"/>
+          </a:xfrm>
+          <a:prstGeom prst="rect">
+            <a:avLst/>
+          </a:prstGeom>
+          <a:solidFill>
+            <a:srgbClr val="E4E1DC"/>
+          </a:solidFill>
+          <a:ln/>
+        </p:spPr>
+      </p:sp>
+      <p:sp>
+        <p:nvSpPr>
+          <p:cNvPr id="22" name="Text 20"/>
+          <p:cNvSpPr/>
+          <p:nvPr/>
+        </p:nvSpPr>
+        <p:spPr>
+          <a:xfrm>
+            <a:off x="8383829" y="5029200"/>
+            <a:ext cx="2710586" cy="320040"/>
+          </a:xfrm>
+          <a:prstGeom prst="rect">
+            <a:avLst/>
+          </a:prstGeom>
+          <a:noFill/>
+          <a:ln/>
+        </p:spPr>
+        <p:txBody>
+          <a:bodyPr wrap="square" lIns="0" tIns="0" rIns="0" bIns="0" rtlCol="0" anchor="t"/>
+          <a:lstStyle/>
+          <a:p>
+            <a:pPr indent="0" marL="0">
+              <a:buNone/>
+            </a:pPr>
+            <a:r>
+              <a:rPr lang="en-US" sz="1200" b="1" dirty="0">
+                <a:solidFill>
+                  <a:srgbClr val="B8772E"/>
+                </a:solidFill>
+                <a:latin typeface="Yu Gothic" pitchFamily="34" charset="0"/>
+                <a:ea typeface="Yu Gothic" pitchFamily="34" charset="-122"/>
+                <a:cs typeface="Yu Gothic" pitchFamily="34" charset="-120"/>
+              </a:rPr>
+              <a:t>→ EMARF / NESTING</a:t>
+            </a:r>
+            <a:endParaRPr lang="en-US" sz="1200" dirty="0"/>
+          </a:p>
+        </p:txBody>
+      </p:sp>
+      <p:sp>
+        <p:nvSpPr>
+          <p:cNvPr id="23" name="Text 21"/>
+          <p:cNvSpPr/>
+          <p:nvPr/>
+        </p:nvSpPr>
+        <p:spPr>
+          <a:xfrm>
+            <a:off x="841248" y="5715000"/>
+            <a:ext cx="10509199" cy="320040"/>
+          </a:xfrm>
+          <a:prstGeom prst="rect">
+            <a:avLst/>
+          </a:prstGeom>
+          <a:noFill/>
+          <a:ln/>
+        </p:spPr>
+        <p:txBody>
+          <a:bodyPr wrap="square" lIns="0" tIns="0" rIns="0" bIns="0" rtlCol="0" anchor="t"/>
+          <a:lstStyle/>
+          <a:p>
+            <a:pPr indent="0" marL="0">
+              <a:buNone/>
+            </a:pPr>
+            <a:r>
+              <a:rPr lang="en-US" sz="1100" dirty="0">
+                <a:solidFill>
+                  <a:srgbClr val="A8A8A8"/>
+                </a:solidFill>
+                <a:latin typeface="Yu Gothic" pitchFamily="34" charset="0"/>
+                <a:ea typeface="Yu Gothic" pitchFamily="34" charset="-122"/>
+                <a:cs typeface="Yu Gothic" pitchFamily="34" charset="-120"/>
+              </a:rPr>
+              <a:t>関連リンク：CMS上で各ソリューションの記事へ接続する想定</a:t>
+            </a:r>
+            <a:endParaRPr lang="en-US" sz="1100" dirty="0"/>
+          </a:p>
+        </p:txBody>
+      </p:sp>
+      <p:sp>
+        <p:nvSpPr>
+          <p:cNvPr id="24" name="Text 22"/>
+          <p:cNvSpPr/>
+          <p:nvPr/>
+        </p:nvSpPr>
+        <p:spPr>
+          <a:xfrm>
+            <a:off x="841248" y="6400800"/>
+            <a:ext cx="7315200" cy="274320"/>
+          </a:xfrm>
+          <a:prstGeom prst="rect">
+            <a:avLst/>
+          </a:prstGeom>
+          <a:noFill/>
+          <a:ln/>
+        </p:spPr>
+        <p:txBody>
+          <a:bodyPr wrap="square" lIns="0" tIns="0" rIns="0" bIns="0" rtlCol="0" anchor="t"/>
+          <a:lstStyle/>
+          <a:p>
+            <a:pPr indent="0" marL="0">
+              <a:buNone/>
+            </a:pPr>
+            <a:r>
+              <a:rPr lang="en-US" sz="900" dirty="0">
+                <a:solidFill>
+                  <a:srgbClr val="A8A8A8"/>
+                </a:solidFill>
+                <a:latin typeface="Yu Gothic" pitchFamily="34" charset="0"/>
+                <a:ea typeface="Yu Gothic" pitchFamily="34" charset="-122"/>
+                <a:cs typeface="Yu Gothic" pitchFamily="34" charset="-120"/>
+              </a:rPr>
+              <a:t>Incubation Team OKR ・ リーダー定例 2026-06-28</a:t>
+            </a:r>
+            <a:endParaRPr lang="en-US" sz="900" dirty="0"/>
+          </a:p>
+        </p:txBody>
+      </p:sp>
+      <p:sp>
+        <p:nvSpPr>
+          <p:cNvPr id="25" name="Text 23"/>
+          <p:cNvSpPr/>
+          <p:nvPr/>
+        </p:nvSpPr>
+        <p:spPr>
+          <a:xfrm>
+            <a:off x="10436047" y="6400800"/>
+            <a:ext cx="914400" cy="274320"/>
+          </a:xfrm>
+          <a:prstGeom prst="rect">
+            <a:avLst/>
+          </a:prstGeom>
+          <a:noFill/>
+          <a:ln/>
+        </p:spPr>
+        <p:txBody>
+          <a:bodyPr wrap="square" lIns="0" tIns="0" rIns="0" bIns="0" rtlCol="0" anchor="t"/>
+          <a:lstStyle/>
+          <a:p>
+            <a:pPr algn="r" indent="0" marL="0">
+              <a:buNone/>
+            </a:pPr>
+            <a:r>
+              <a:rPr lang="en-US" sz="900" dirty="0">
+                <a:solidFill>
+                  <a:srgbClr val="A8A8A8"/>
+                </a:solidFill>
+                <a:latin typeface="Yu Gothic" pitchFamily="34" charset="0"/>
+                <a:ea typeface="Yu Gothic" pitchFamily="34" charset="-122"/>
+                <a:cs typeface="Yu Gothic" pitchFamily="34" charset="-120"/>
+              </a:rPr>
+              <a:t>13</a:t>
+            </a:r>
+            <a:endParaRPr lang="en-US" sz="900" dirty="0"/>
+          </a:p>
+        </p:txBody>
+      </p:sp>
+    </p:spTree>
+  </p:cSld>
+  <p:clrMapOvr>
+    <a:masterClrMapping/>
+  </p:clrMapOvr>
+</p:sld>
+</file>
+
+<file path=ppt/slides/slide14.xml><?xml version="1.0" encoding="utf-8"?>
+<p:sld xmlns:a="http://schemas.openxmlformats.org/drawingml/2006/main" xmlns:r="http://schemas.openxmlformats.org/officeDocument/2006/relationships" xmlns:p="http://schemas.openxmlformats.org/presentationml/2006/main">
+  <p:cSld name="Slide 14">
+    <p:bg>
+      <p:bgPr>
+        <a:solidFill>
+          <a:srgbClr val="FDFCFA"/>
+        </a:solidFill>
+      </p:bgPr>
+    </p:bg>
+    <p:spTree>
+      <p:nvGrpSpPr>
+        <p:cNvPr id="1" name=""/>
+        <p:cNvGrpSpPr/>
+        <p:nvPr/>
+      </p:nvGrpSpPr>
+      <p:grpSpPr>
+        <a:xfrm>
+          <a:off x="0" y="0"/>
+          <a:ext cx="0" cy="0"/>
+          <a:chOff x="0" y="0"/>
+          <a:chExt cx="0" cy="0"/>
+        </a:xfrm>
+      </p:grpSpPr>
+      <p:sp>
+        <p:nvSpPr>
+          <p:cNvPr id="2" name="Shape 0"/>
+          <p:cNvSpPr/>
+          <p:nvPr/>
+        </p:nvSpPr>
+        <p:spPr>
+          <a:xfrm>
+            <a:off x="841248" y="566928"/>
+            <a:ext cx="384048" cy="77724"/>
+          </a:xfrm>
+          <a:prstGeom prst="rect">
+            <a:avLst/>
+          </a:prstGeom>
+          <a:solidFill>
+            <a:srgbClr val="B8772E"/>
+          </a:solidFill>
+          <a:ln/>
+        </p:spPr>
+      </p:sp>
+      <p:sp>
+        <p:nvSpPr>
+          <p:cNvPr id="3" name="Text 1"/>
+          <p:cNvSpPr/>
+          <p:nvPr/>
+        </p:nvSpPr>
+        <p:spPr>
+          <a:xfrm>
+            <a:off x="841248" y="731520"/>
+            <a:ext cx="10509199" cy="365760"/>
+          </a:xfrm>
+          <a:prstGeom prst="rect">
+            <a:avLst/>
+          </a:prstGeom>
+          <a:noFill/>
+          <a:ln/>
+        </p:spPr>
+        <p:txBody>
+          <a:bodyPr wrap="square" lIns="0" tIns="0" rIns="0" bIns="0" rtlCol="0" anchor="t"/>
+          <a:lstStyle/>
+          <a:p>
+            <a:pPr indent="0" marL="0">
+              <a:buNone/>
+            </a:pPr>
+            <a:r>
+              <a:rPr lang="en-US" sz="1350" b="1" dirty="0">
+                <a:solidFill>
+                  <a:srgbClr val="B8772E"/>
+                </a:solidFill>
+                <a:latin typeface="Yu Gothic" pitchFamily="34" charset="0"/>
+                <a:ea typeface="Yu Gothic" pitchFamily="34" charset="-122"/>
+                <a:cs typeface="Yu Gothic" pitchFamily="34" charset="-120"/>
+              </a:rPr>
+              <a:t>What we do ｜ Project</a:t>
+            </a:r>
+            <a:endParaRPr lang="en-US" sz="1350" dirty="0"/>
+          </a:p>
+        </p:txBody>
+      </p:sp>
+      <p:sp>
+        <p:nvSpPr>
+          <p:cNvPr id="4" name="Text 2"/>
+          <p:cNvSpPr/>
+          <p:nvPr/>
+        </p:nvSpPr>
+        <p:spPr>
+          <a:xfrm>
+            <a:off x="841248" y="1078992"/>
+            <a:ext cx="10509199" cy="868680"/>
+          </a:xfrm>
+          <a:prstGeom prst="rect">
+            <a:avLst/>
+          </a:prstGeom>
+          <a:noFill/>
+          <a:ln/>
+        </p:spPr>
+        <p:txBody>
+          <a:bodyPr wrap="square" lIns="0" tIns="0" rIns="0" bIns="0" rtlCol="0" anchor="t"/>
+          <a:lstStyle/>
+          <a:p>
+            <a:pPr indent="0" marL="0">
+              <a:lnSpc>
+                <a:spcPct val="105000"/>
+              </a:lnSpc>
+              <a:buNone/>
+            </a:pPr>
+            <a:r>
+              <a:rPr lang="en-US" sz="2600" b="1" dirty="0">
+                <a:solidFill>
+                  <a:srgbClr val="222222"/>
+                </a:solidFill>
+                <a:latin typeface="Yu Gothic" pitchFamily="34" charset="0"/>
+                <a:ea typeface="Yu Gothic" pitchFamily="34" charset="-122"/>
+                <a:cs typeface="Yu Gothic" pitchFamily="34" charset="-120"/>
+              </a:rPr>
+              <a:t>関連プロジェクト（CMS掲載予定）</a:t>
+            </a:r>
+            <a:endParaRPr lang="en-US" sz="2600" dirty="0"/>
+          </a:p>
+        </p:txBody>
+      </p:sp>
+      <p:sp>
+        <p:nvSpPr>
+          <p:cNvPr id="5" name="Text 3"/>
+          <p:cNvSpPr/>
+          <p:nvPr/>
+        </p:nvSpPr>
+        <p:spPr>
+          <a:xfrm>
+            <a:off x="841248" y="1783080"/>
+            <a:ext cx="10509199" cy="457200"/>
+          </a:xfrm>
+          <a:prstGeom prst="rect">
+            <a:avLst/>
+          </a:prstGeom>
+          <a:noFill/>
+          <a:ln/>
+        </p:spPr>
+        <p:txBody>
+          <a:bodyPr wrap="square" lIns="0" tIns="0" rIns="0" bIns="0" rtlCol="0" anchor="t"/>
+          <a:lstStyle/>
+          <a:p>
+            <a:pPr indent="0" marL="0">
+              <a:lnSpc>
+                <a:spcPct val="125000"/>
+              </a:lnSpc>
+              <a:buNone/>
+            </a:pPr>
+            <a:r>
+              <a:rPr lang="en-US" sz="1100" dirty="0">
+                <a:solidFill>
+                  <a:srgbClr val="707070"/>
+                </a:solidFill>
+                <a:latin typeface="Yu Gothic" pitchFamily="34" charset="0"/>
+                <a:ea typeface="Yu Gothic" pitchFamily="34" charset="-122"/>
+                <a:cs typeface="Yu Gothic" pitchFamily="34" charset="-120"/>
+              </a:rPr>
+              <a:t>想定タグ：教育／アプリ開発／林業／地域／共創／ShopBot導入支援／拠点開拓／カルチャー協業？　※全体で使うタグと合わせて調整</a:t>
+            </a:r>
+            <a:endParaRPr lang="en-US" sz="1100" dirty="0"/>
+          </a:p>
+        </p:txBody>
+      </p:sp>
+      <p:graphicFrame>
+        <p:nvGraphicFramePr>
+          <p:cNvPr id="15" name="Table 0"/>
+          <p:cNvGraphicFramePr>
+            <a:graphicFrameLocks noGrp="1"/>
+          </p:cNvGraphicFramePr>
+          <p:nvPr>
+            <p:extLst>
+              <p:ext uri="{D42A27DB-BD31-4B8C-83A1-F6EECF244321}">
+                <p14:modId xmlns:p14="http://schemas.microsoft.com/office/powerpoint/2010/main" val="1579011935"/>
+              </p:ext>
+            </p:extLst>
+          </p:nvPr>
+        </p:nvGraphicFramePr>
+        <p:xfrm>
+          <a:off x="841248" y="2468880"/>
+          <a:ext cx="10509199" cy="914400"/>
+        </p:xfrm>
+        <a:graphic>
+          <a:graphicData uri="http://schemas.openxmlformats.org/drawingml/2006/table">
+            <a:tbl>
+              <a:tblPr/>
+              <a:tblGrid>
+                <a:gridCol w="914400"/>
+                <a:gridCol w="4572000"/>
+                <a:gridCol w="5022799"/>
+              </a:tblGrid>
+              <a:tr h="384048">
+                <a:tc>
+                  <a:txBody>
+                    <a:bodyPr/>
+                    <a:lstStyle/>
+                    <a:p>
+                      <a:pPr indent="0" marL="0">
+                        <a:buNone/>
+                      </a:pPr>
+                      <a:r>
+                        <a:rPr lang="en-US" sz="1200" b="1" dirty="0">
+                          <a:solidFill>
+                            <a:srgbClr val="FFFFFF"/>
+                          </a:solidFill>
+                          <a:latin typeface="Yu Gothic" pitchFamily="34" charset="0"/>
+                          <a:ea typeface="Yu Gothic" pitchFamily="34" charset="-122"/>
+                          <a:cs typeface="Yu Gothic" pitchFamily="34" charset="-120"/>
+                        </a:rPr>
+                        <a:t>PJ</a:t>
+                      </a:r>
+                      <a:endParaRPr lang="en-US" sz="1200" dirty="0">
+                        <a:latin typeface="Yu Gothic" charset="0"/>
+                        <a:ea typeface="Yu Gothic" charset="0"/>
+                        <a:cs typeface="Yu Gothic" charset="0"/>
+                      </a:endParaRPr>
+                    </a:p>
+                  </a:txBody>
+                  <a:tcPr marL="101600" marR="101600" marT="38100" marB="38100" anchor="ctr">
+                    <a:lnL w="6350" cap="flat" cmpd="sng" algn="ctr">
+                      <a:solidFill>
+                        <a:srgbClr val="E4E1DC"/>
+                      </a:solidFill>
+                      <a:prstDash val="solid"/>
+                      <a:round/>
+                      <a:headEnd type="none" w="med" len="med"/>
+                      <a:tailEnd type="none" w="med" len="med"/>
+                    </a:lnL>
+                    <a:lnR w="6350" cap="flat" cmpd="sng" algn="ctr">
+                      <a:solidFill>
+                        <a:srgbClr val="E4E1DC"/>
+                      </a:solidFill>
+                      <a:prstDash val="solid"/>
+                      <a:round/>
+                      <a:headEnd type="none" w="med" len="med"/>
+                      <a:tailEnd type="none" w="med" len="med"/>
+                    </a:lnR>
+                    <a:lnT w="6350" cap="flat" cmpd="sng" algn="ctr">
+                      <a:solidFill>
+                        <a:srgbClr val="E4E1DC"/>
+                      </a:solidFill>
+                      <a:prstDash val="solid"/>
+                      <a:round/>
+                      <a:headEnd type="none" w="med" len="med"/>
+                      <a:tailEnd type="none" w="med" len="med"/>
+                    </a:lnT>
+                    <a:lnB w="6350" cap="flat" cmpd="sng" algn="ctr">
+                      <a:solidFill>
+                        <a:srgbClr val="E4E1DC"/>
+                      </a:solidFill>
+                      <a:prstDash val="solid"/>
+                      <a:round/>
+                      <a:headEnd type="none" w="med" len="med"/>
+                      <a:tailEnd type="none" w="med" len="med"/>
+                    </a:lnB>
+                    <a:solidFill>
+                      <a:srgbClr val="222222"/>
+                    </a:solidFill>
+                  </a:tcPr>
+                </a:tc>
+                <a:tc>
+                  <a:txBody>
+                    <a:bodyPr/>
+                    <a:lstStyle/>
+                    <a:p>
+                      <a:pPr indent="0" marL="0">
+                        <a:buNone/>
+                      </a:pPr>
+                      <a:r>
+                        <a:rPr lang="en-US" sz="1200" b="1" dirty="0">
+                          <a:solidFill>
+                            <a:srgbClr val="FFFFFF"/>
+                          </a:solidFill>
+                          <a:latin typeface="Yu Gothic" pitchFamily="34" charset="0"/>
+                          <a:ea typeface="Yu Gothic" pitchFamily="34" charset="-122"/>
+                          <a:cs typeface="Yu Gothic" pitchFamily="34" charset="-120"/>
+                        </a:rPr>
+                        <a:t>プロジェクト</a:t>
+                      </a:r>
+                      <a:endParaRPr lang="en-US" sz="1200" dirty="0">
+                        <a:latin typeface="Yu Gothic" charset="0"/>
+                        <a:ea typeface="Yu Gothic" charset="0"/>
+                        <a:cs typeface="Yu Gothic" charset="0"/>
+                      </a:endParaRPr>
+                    </a:p>
+                  </a:txBody>
+                  <a:tcPr marL="101600" marR="101600" marT="38100" marB="38100" anchor="ctr">
+                    <a:lnL w="6350" cap="flat" cmpd="sng" algn="ctr">
+                      <a:solidFill>
+                        <a:srgbClr val="E4E1DC"/>
+                      </a:solidFill>
+                      <a:prstDash val="solid"/>
+                      <a:round/>
+                      <a:headEnd type="none" w="med" len="med"/>
+                      <a:tailEnd type="none" w="med" len="med"/>
+                    </a:lnL>
+                    <a:lnR w="6350" cap="flat" cmpd="sng" algn="ctr">
+                      <a:solidFill>
+                        <a:srgbClr val="E4E1DC"/>
+                      </a:solidFill>
+                      <a:prstDash val="solid"/>
+                      <a:round/>
+                      <a:headEnd type="none" w="med" len="med"/>
+                      <a:tailEnd type="none" w="med" len="med"/>
+                    </a:lnR>
+                    <a:lnT w="6350" cap="flat" cmpd="sng" algn="ctr">
+                      <a:solidFill>
+                        <a:srgbClr val="E4E1DC"/>
+                      </a:solidFill>
+                      <a:prstDash val="solid"/>
+                      <a:round/>
+                      <a:headEnd type="none" w="med" len="med"/>
+                      <a:tailEnd type="none" w="med" len="med"/>
+                    </a:lnT>
+                    <a:lnB w="6350" cap="flat" cmpd="sng" algn="ctr">
+                      <a:solidFill>
+                        <a:srgbClr val="E4E1DC"/>
+                      </a:solidFill>
+                      <a:prstDash val="solid"/>
+                      <a:round/>
+                      <a:headEnd type="none" w="med" len="med"/>
+                      <a:tailEnd type="none" w="med" len="med"/>
+                    </a:lnB>
+                    <a:solidFill>
+                      <a:srgbClr val="222222"/>
+                    </a:solidFill>
+                  </a:tcPr>
+                </a:tc>
+                <a:tc>
+                  <a:txBody>
+                    <a:bodyPr/>
+                    <a:lstStyle/>
+                    <a:p>
+                      <a:pPr indent="0" marL="0">
+                        <a:buNone/>
+                      </a:pPr>
+                      <a:r>
+                        <a:rPr lang="en-US" sz="1200" b="1" dirty="0">
+                          <a:solidFill>
+                            <a:srgbClr val="FFFFFF"/>
+                          </a:solidFill>
+                          <a:latin typeface="Yu Gothic" pitchFamily="34" charset="0"/>
+                          <a:ea typeface="Yu Gothic" pitchFamily="34" charset="-122"/>
+                          <a:cs typeface="Yu Gothic" pitchFamily="34" charset="-120"/>
+                        </a:rPr>
+                        <a:t>メモ／ステータス</a:t>
+                      </a:r>
+                      <a:endParaRPr lang="en-US" sz="1200" dirty="0">
+                        <a:latin typeface="Yu Gothic" charset="0"/>
+                        <a:ea typeface="Yu Gothic" charset="0"/>
+                        <a:cs typeface="Yu Gothic" charset="0"/>
+                      </a:endParaRPr>
+                    </a:p>
+                  </a:txBody>
+                  <a:tcPr marL="101600" marR="101600" marT="38100" marB="38100" anchor="ctr">
+                    <a:lnL w="6350" cap="flat" cmpd="sng" algn="ctr">
+                      <a:solidFill>
+                        <a:srgbClr val="E4E1DC"/>
+                      </a:solidFill>
+                      <a:prstDash val="solid"/>
+                      <a:round/>
+                      <a:headEnd type="none" w="med" len="med"/>
+                      <a:tailEnd type="none" w="med" len="med"/>
+                    </a:lnL>
+                    <a:lnR w="6350" cap="flat" cmpd="sng" algn="ctr">
+                      <a:solidFill>
+                        <a:srgbClr val="E4E1DC"/>
+                      </a:solidFill>
+                      <a:prstDash val="solid"/>
+                      <a:round/>
+                      <a:headEnd type="none" w="med" len="med"/>
+                      <a:tailEnd type="none" w="med" len="med"/>
+                    </a:lnR>
+                    <a:lnT w="6350" cap="flat" cmpd="sng" algn="ctr">
+                      <a:solidFill>
+                        <a:srgbClr val="E4E1DC"/>
+                      </a:solidFill>
+                      <a:prstDash val="solid"/>
+                      <a:round/>
+                      <a:headEnd type="none" w="med" len="med"/>
+                      <a:tailEnd type="none" w="med" len="med"/>
+                    </a:lnT>
+                    <a:lnB w="6350" cap="flat" cmpd="sng" algn="ctr">
+                      <a:solidFill>
+                        <a:srgbClr val="E4E1DC"/>
+                      </a:solidFill>
+                      <a:prstDash val="solid"/>
+                      <a:round/>
+                      <a:headEnd type="none" w="med" len="med"/>
+                      <a:tailEnd type="none" w="med" len="med"/>
+                    </a:lnB>
+                    <a:solidFill>
+                      <a:srgbClr val="222222"/>
+                    </a:solidFill>
+                  </a:tcPr>
+                </a:tc>
+              </a:tr>
+              <a:tr h="365760">
+                <a:tc>
+                  <a:txBody>
+                    <a:bodyPr/>
+                    <a:lstStyle/>
+                    <a:p>
+                      <a:pPr indent="0" marL="0">
+                        <a:buNone/>
+                      </a:pPr>
+                      <a:r>
+                        <a:rPr lang="en-US" sz="1200" b="1" dirty="0">
+                          <a:solidFill>
+                            <a:srgbClr val="B8772E"/>
+                          </a:solidFill>
+                          <a:latin typeface="Yu Gothic" pitchFamily="34" charset="0"/>
+                          <a:ea typeface="Yu Gothic" pitchFamily="34" charset="-122"/>
+                          <a:cs typeface="Yu Gothic" pitchFamily="34" charset="-120"/>
+                        </a:rPr>
+                        <a:t>PJ1</a:t>
+                      </a:r>
+                      <a:endParaRPr lang="en-US" sz="1200" dirty="0">
+                        <a:latin typeface="Yu Gothic" charset="0"/>
+                        <a:ea typeface="Yu Gothic" charset="0"/>
+                        <a:cs typeface="Yu Gothic" charset="0"/>
+                      </a:endParaRPr>
+                    </a:p>
+                  </a:txBody>
+                  <a:tcPr marL="101600" marR="101600" marT="38100" marB="38100" anchor="ctr">
+                    <a:lnL w="6350" cap="flat" cmpd="sng" algn="ctr">
+                      <a:solidFill>
+                        <a:srgbClr val="E4E1DC"/>
+                      </a:solidFill>
+                      <a:prstDash val="solid"/>
+                      <a:round/>
+                      <a:headEnd type="none" w="med" len="med"/>
+                      <a:tailEnd type="none" w="med" len="med"/>
+                    </a:lnL>
+                    <a:lnR w="6350" cap="flat" cmpd="sng" algn="ctr">
+                      <a:solidFill>
+                        <a:srgbClr val="E4E1DC"/>
+                      </a:solidFill>
+                      <a:prstDash val="solid"/>
+                      <a:round/>
+                      <a:headEnd type="none" w="med" len="med"/>
+                      <a:tailEnd type="none" w="med" len="med"/>
+                    </a:lnR>
+                    <a:lnT w="6350" cap="flat" cmpd="sng" algn="ctr">
+                      <a:solidFill>
+                        <a:srgbClr val="E4E1DC"/>
+                      </a:solidFill>
+                      <a:prstDash val="solid"/>
+                      <a:round/>
+                      <a:headEnd type="none" w="med" len="med"/>
+                      <a:tailEnd type="none" w="med" len="med"/>
+                    </a:lnT>
+                    <a:lnB w="6350" cap="flat" cmpd="sng" algn="ctr">
+                      <a:solidFill>
+                        <a:srgbClr val="E4E1DC"/>
+                      </a:solidFill>
+                      <a:prstDash val="solid"/>
+                      <a:round/>
+                      <a:headEnd type="none" w="med" len="med"/>
+                      <a:tailEnd type="none" w="med" len="med"/>
+                    </a:lnB>
+                    <a:solidFill>
+                      <a:srgbClr val="FFFFFF"/>
+                    </a:solidFill>
+                  </a:tcPr>
+                </a:tc>
+                <a:tc>
+                  <a:txBody>
+                    <a:bodyPr/>
+                    <a:lstStyle/>
+                    <a:p>
+                      <a:pPr indent="0" marL="0">
+                        <a:buNone/>
+                      </a:pPr>
+                      <a:r>
+                        <a:rPr lang="en-US" sz="1200" b="1" dirty="0">
+                          <a:solidFill>
+                            <a:srgbClr val="222222"/>
+                          </a:solidFill>
+                          <a:latin typeface="Yu Gothic" pitchFamily="34" charset="0"/>
+                          <a:ea typeface="Yu Gothic" pitchFamily="34" charset="-122"/>
+                          <a:cs typeface="Yu Gothic" pitchFamily="34" charset="-120"/>
+                        </a:rPr>
+                        <a:t>倉吉探求学習プログラム</a:t>
+                      </a:r>
+                      <a:endParaRPr lang="en-US" sz="1200" dirty="0">
+                        <a:latin typeface="Yu Gothic" charset="0"/>
+                        <a:ea typeface="Yu Gothic" charset="0"/>
+                        <a:cs typeface="Yu Gothic" charset="0"/>
+                      </a:endParaRPr>
+                    </a:p>
+                  </a:txBody>
+                  <a:tcPr marL="101600" marR="101600" marT="38100" marB="38100" anchor="ctr">
+                    <a:lnL w="6350" cap="flat" cmpd="sng" algn="ctr">
+                      <a:solidFill>
+                        <a:srgbClr val="E4E1DC"/>
+                      </a:solidFill>
+                      <a:prstDash val="solid"/>
+                      <a:round/>
+                      <a:headEnd type="none" w="med" len="med"/>
+                      <a:tailEnd type="none" w="med" len="med"/>
+                    </a:lnL>
+                    <a:lnR w="6350" cap="flat" cmpd="sng" algn="ctr">
+                      <a:solidFill>
+                        <a:srgbClr val="E4E1DC"/>
+                      </a:solidFill>
+                      <a:prstDash val="solid"/>
+                      <a:round/>
+                      <a:headEnd type="none" w="med" len="med"/>
+                      <a:tailEnd type="none" w="med" len="med"/>
+                    </a:lnR>
+                    <a:lnT w="6350" cap="flat" cmpd="sng" algn="ctr">
+                      <a:solidFill>
+                        <a:srgbClr val="E4E1DC"/>
+                      </a:solidFill>
+                      <a:prstDash val="solid"/>
+                      <a:round/>
+                      <a:headEnd type="none" w="med" len="med"/>
+                      <a:tailEnd type="none" w="med" len="med"/>
+                    </a:lnT>
+                    <a:lnB w="6350" cap="flat" cmpd="sng" algn="ctr">
+                      <a:solidFill>
+                        <a:srgbClr val="E4E1DC"/>
+                      </a:solidFill>
+                      <a:prstDash val="solid"/>
+                      <a:round/>
+                      <a:headEnd type="none" w="med" len="med"/>
+                      <a:tailEnd type="none" w="med" len="med"/>
+                    </a:lnB>
+                    <a:solidFill>
+                      <a:srgbClr val="FFFFFF"/>
+                    </a:solidFill>
+                  </a:tcPr>
+                </a:tc>
+                <a:tc>
+                  <a:txBody>
+                    <a:bodyPr/>
+                    <a:lstStyle/>
+                    <a:p>
+                      <a:pPr indent="0" marL="0">
+                        <a:buNone/>
+                      </a:pPr>
+                      <a:endParaRPr lang="en-US" sz="1100" dirty="0">
+                        <a:latin typeface="Yu Gothic" charset="0"/>
+                        <a:ea typeface="Yu Gothic" charset="0"/>
+                        <a:cs typeface="Yu Gothic" charset="0"/>
+                      </a:endParaRPr>
+                    </a:p>
+                  </a:txBody>
+                  <a:tcPr marL="101600" marR="101600" marT="38100" marB="38100" anchor="ctr">
+                    <a:lnL w="6350" cap="flat" cmpd="sng" algn="ctr">
+                      <a:solidFill>
+                        <a:srgbClr val="E4E1DC"/>
+                      </a:solidFill>
+                      <a:prstDash val="solid"/>
+                      <a:round/>
+                      <a:headEnd type="none" w="med" len="med"/>
+                      <a:tailEnd type="none" w="med" len="med"/>
+                    </a:lnL>
+                    <a:lnR w="6350" cap="flat" cmpd="sng" algn="ctr">
+                      <a:solidFill>
+                        <a:srgbClr val="E4E1DC"/>
+                      </a:solidFill>
+                      <a:prstDash val="solid"/>
+                      <a:round/>
+                      <a:headEnd type="none" w="med" len="med"/>
+                      <a:tailEnd type="none" w="med" len="med"/>
+                    </a:lnR>
+                    <a:lnT w="6350" cap="flat" cmpd="sng" algn="ctr">
+                      <a:solidFill>
+                        <a:srgbClr val="E4E1DC"/>
+                      </a:solidFill>
+                      <a:prstDash val="solid"/>
+                      <a:round/>
+                      <a:headEnd type="none" w="med" len="med"/>
+                      <a:tailEnd type="none" w="med" len="med"/>
+                    </a:lnT>
+                    <a:lnB w="6350" cap="flat" cmpd="sng" algn="ctr">
+                      <a:solidFill>
+                        <a:srgbClr val="E4E1DC"/>
+                      </a:solidFill>
+                      <a:prstDash val="solid"/>
+                      <a:round/>
+                      <a:headEnd type="none" w="med" len="med"/>
+                      <a:tailEnd type="none" w="med" len="med"/>
+                    </a:lnB>
+                    <a:solidFill>
+                      <a:srgbClr val="FFFFFF"/>
+                    </a:solidFill>
+                  </a:tcPr>
+                </a:tc>
+              </a:tr>
+              <a:tr h="365760">
+                <a:tc>
+                  <a:txBody>
+                    <a:bodyPr/>
+                    <a:lstStyle/>
+                    <a:p>
+                      <a:pPr indent="0" marL="0">
+                        <a:buNone/>
+                      </a:pPr>
+                      <a:r>
+                        <a:rPr lang="en-US" sz="1200" b="1" dirty="0">
+                          <a:solidFill>
+                            <a:srgbClr val="B8772E"/>
+                          </a:solidFill>
+                          <a:latin typeface="Yu Gothic" pitchFamily="34" charset="0"/>
+                          <a:ea typeface="Yu Gothic" pitchFamily="34" charset="-122"/>
+                          <a:cs typeface="Yu Gothic" pitchFamily="34" charset="-120"/>
+                        </a:rPr>
+                        <a:t>PJ2</a:t>
+                      </a:r>
+                      <a:endParaRPr lang="en-US" sz="1200" dirty="0">
+                        <a:latin typeface="Yu Gothic" charset="0"/>
+                        <a:ea typeface="Yu Gothic" charset="0"/>
+                        <a:cs typeface="Yu Gothic" charset="0"/>
+                      </a:endParaRPr>
+                    </a:p>
+                  </a:txBody>
+                  <a:tcPr marL="101600" marR="101600" marT="38100" marB="38100" anchor="ctr">
+                    <a:lnL w="6350" cap="flat" cmpd="sng" algn="ctr">
+                      <a:solidFill>
+                        <a:srgbClr val="E4E1DC"/>
+                      </a:solidFill>
+                      <a:prstDash val="solid"/>
+                      <a:round/>
+                      <a:headEnd type="none" w="med" len="med"/>
+                      <a:tailEnd type="none" w="med" len="med"/>
+                    </a:lnL>
+                    <a:lnR w="6350" cap="flat" cmpd="sng" algn="ctr">
+                      <a:solidFill>
+                        <a:srgbClr val="E4E1DC"/>
+                      </a:solidFill>
+                      <a:prstDash val="solid"/>
+                      <a:round/>
+                      <a:headEnd type="none" w="med" len="med"/>
+                      <a:tailEnd type="none" w="med" len="med"/>
+                    </a:lnR>
+                    <a:lnT w="6350" cap="flat" cmpd="sng" algn="ctr">
+                      <a:solidFill>
+                        <a:srgbClr val="E4E1DC"/>
+                      </a:solidFill>
+                      <a:prstDash val="solid"/>
+                      <a:round/>
+                      <a:headEnd type="none" w="med" len="med"/>
+                      <a:tailEnd type="none" w="med" len="med"/>
+                    </a:lnT>
+                    <a:lnB w="6350" cap="flat" cmpd="sng" algn="ctr">
+                      <a:solidFill>
+                        <a:srgbClr val="E4E1DC"/>
+                      </a:solidFill>
+                      <a:prstDash val="solid"/>
+                      <a:round/>
+                      <a:headEnd type="none" w="med" len="med"/>
+                      <a:tailEnd type="none" w="med" len="med"/>
+                    </a:lnB>
+                    <a:solidFill>
+                      <a:srgbClr val="F7F2EA"/>
+                    </a:solidFill>
+                  </a:tcPr>
+                </a:tc>
+                <a:tc>
+                  <a:txBody>
+                    <a:bodyPr/>
+                    <a:lstStyle/>
+                    <a:p>
+                      <a:pPr indent="0" marL="0">
+                        <a:buNone/>
+                      </a:pPr>
+                      <a:r>
+                        <a:rPr lang="en-US" sz="1200" b="1" dirty="0">
+                          <a:solidFill>
+                            <a:srgbClr val="222222"/>
+                          </a:solidFill>
+                          <a:latin typeface="Yu Gothic" pitchFamily="34" charset="0"/>
+                          <a:ea typeface="Yu Gothic" pitchFamily="34" charset="-122"/>
+                          <a:cs typeface="Yu Gothic" pitchFamily="34" charset="-120"/>
+                        </a:rPr>
+                        <a:t>名古屋キャリア教育授業　2022–2025</a:t>
+                      </a:r>
+                      <a:endParaRPr lang="en-US" sz="1200" dirty="0">
+                        <a:latin typeface="Yu Gothic" charset="0"/>
+                        <a:ea typeface="Yu Gothic" charset="0"/>
+                        <a:cs typeface="Yu Gothic" charset="0"/>
+                      </a:endParaRPr>
+                    </a:p>
+                  </a:txBody>
+                  <a:tcPr marL="101600" marR="101600" marT="38100" marB="38100" anchor="ctr">
+                    <a:lnL w="6350" cap="flat" cmpd="sng" algn="ctr">
+                      <a:solidFill>
+                        <a:srgbClr val="E4E1DC"/>
+                      </a:solidFill>
+                      <a:prstDash val="solid"/>
+                      <a:round/>
+                      <a:headEnd type="none" w="med" len="med"/>
+                      <a:tailEnd type="none" w="med" len="med"/>
+                    </a:lnL>
+                    <a:lnR w="6350" cap="flat" cmpd="sng" algn="ctr">
+                      <a:solidFill>
+                        <a:srgbClr val="E4E1DC"/>
+                      </a:solidFill>
+                      <a:prstDash val="solid"/>
+                      <a:round/>
+                      <a:headEnd type="none" w="med" len="med"/>
+                      <a:tailEnd type="none" w="med" len="med"/>
+                    </a:lnR>
+                    <a:lnT w="6350" cap="flat" cmpd="sng" algn="ctr">
+                      <a:solidFill>
+                        <a:srgbClr val="E4E1DC"/>
+                      </a:solidFill>
+                      <a:prstDash val="solid"/>
+                      <a:round/>
+                      <a:headEnd type="none" w="med" len="med"/>
+                      <a:tailEnd type="none" w="med" len="med"/>
+                    </a:lnT>
+                    <a:lnB w="6350" cap="flat" cmpd="sng" algn="ctr">
+                      <a:solidFill>
+                        <a:srgbClr val="E4E1DC"/>
+                      </a:solidFill>
+                      <a:prstDash val="solid"/>
+                      <a:round/>
+                      <a:headEnd type="none" w="med" len="med"/>
+                      <a:tailEnd type="none" w="med" len="med"/>
+                    </a:lnB>
+                    <a:solidFill>
+                      <a:srgbClr val="F7F2EA"/>
+                    </a:solidFill>
+                  </a:tcPr>
+                </a:tc>
+                <a:tc>
+                  <a:txBody>
+                    <a:bodyPr/>
+                    <a:lstStyle/>
+                    <a:p>
+                      <a:pPr indent="0" marL="0">
+                        <a:buNone/>
+                      </a:pPr>
+                      <a:endParaRPr lang="en-US" sz="1100" dirty="0">
+                        <a:latin typeface="Yu Gothic" charset="0"/>
+                        <a:ea typeface="Yu Gothic" charset="0"/>
+                        <a:cs typeface="Yu Gothic" charset="0"/>
+                      </a:endParaRPr>
+                    </a:p>
+                  </a:txBody>
+                  <a:tcPr marL="101600" marR="101600" marT="38100" marB="38100" anchor="ctr">
+                    <a:lnL w="6350" cap="flat" cmpd="sng" algn="ctr">
+                      <a:solidFill>
+                        <a:srgbClr val="E4E1DC"/>
+                      </a:solidFill>
+                      <a:prstDash val="solid"/>
+                      <a:round/>
+                      <a:headEnd type="none" w="med" len="med"/>
+                      <a:tailEnd type="none" w="med" len="med"/>
+                    </a:lnL>
+                    <a:lnR w="6350" cap="flat" cmpd="sng" algn="ctr">
+                      <a:solidFill>
+                        <a:srgbClr val="E4E1DC"/>
+                      </a:solidFill>
+                      <a:prstDash val="solid"/>
+                      <a:round/>
+                      <a:headEnd type="none" w="med" len="med"/>
+                      <a:tailEnd type="none" w="med" len="med"/>
+                    </a:lnR>
+                    <a:lnT w="6350" cap="flat" cmpd="sng" algn="ctr">
+                      <a:solidFill>
+                        <a:srgbClr val="E4E1DC"/>
+                      </a:solidFill>
+                      <a:prstDash val="solid"/>
+                      <a:round/>
+                      <a:headEnd type="none" w="med" len="med"/>
+                      <a:tailEnd type="none" w="med" len="med"/>
+                    </a:lnT>
+                    <a:lnB w="6350" cap="flat" cmpd="sng" algn="ctr">
+                      <a:solidFill>
+                        <a:srgbClr val="E4E1DC"/>
+                      </a:solidFill>
+                      <a:prstDash val="solid"/>
+                      <a:round/>
+                      <a:headEnd type="none" w="med" len="med"/>
+                      <a:tailEnd type="none" w="med" len="med"/>
+                    </a:lnB>
+                    <a:solidFill>
+                      <a:srgbClr val="F7F2EA"/>
+                    </a:solidFill>
+                  </a:tcPr>
+                </a:tc>
+              </a:tr>
+              <a:tr h="365760">
+                <a:tc>
+                  <a:txBody>
+                    <a:bodyPr/>
+                    <a:lstStyle/>
+                    <a:p>
+                      <a:pPr indent="0" marL="0">
+                        <a:buNone/>
+                      </a:pPr>
+                      <a:r>
+                        <a:rPr lang="en-US" sz="1200" b="1" dirty="0">
+                          <a:solidFill>
+                            <a:srgbClr val="B8772E"/>
+                          </a:solidFill>
+                          <a:latin typeface="Yu Gothic" pitchFamily="34" charset="0"/>
+                          <a:ea typeface="Yu Gothic" pitchFamily="34" charset="-122"/>
+                          <a:cs typeface="Yu Gothic" pitchFamily="34" charset="-120"/>
+                        </a:rPr>
+                        <a:t>PJ3</a:t>
+                      </a:r>
+                      <a:endParaRPr lang="en-US" sz="1200" dirty="0">
+                        <a:latin typeface="Yu Gothic" charset="0"/>
+                        <a:ea typeface="Yu Gothic" charset="0"/>
+                        <a:cs typeface="Yu Gothic" charset="0"/>
+                      </a:endParaRPr>
+                    </a:p>
+                  </a:txBody>
+                  <a:tcPr marL="101600" marR="101600" marT="38100" marB="38100" anchor="ctr">
+                    <a:lnL w="6350" cap="flat" cmpd="sng" algn="ctr">
+                      <a:solidFill>
+                        <a:srgbClr val="E4E1DC"/>
+                      </a:solidFill>
+                      <a:prstDash val="solid"/>
+                      <a:round/>
+                      <a:headEnd type="none" w="med" len="med"/>
+                      <a:tailEnd type="none" w="med" len="med"/>
+                    </a:lnL>
+                    <a:lnR w="6350" cap="flat" cmpd="sng" algn="ctr">
+                      <a:solidFill>
+                        <a:srgbClr val="E4E1DC"/>
+                      </a:solidFill>
+                      <a:prstDash val="solid"/>
+                      <a:round/>
+                      <a:headEnd type="none" w="med" len="med"/>
+                      <a:tailEnd type="none" w="med" len="med"/>
+                    </a:lnR>
+                    <a:lnT w="6350" cap="flat" cmpd="sng" algn="ctr">
+                      <a:solidFill>
+                        <a:srgbClr val="E4E1DC"/>
+                      </a:solidFill>
+                      <a:prstDash val="solid"/>
+                      <a:round/>
+                      <a:headEnd type="none" w="med" len="med"/>
+                      <a:tailEnd type="none" w="med" len="med"/>
+                    </a:lnT>
+                    <a:lnB w="6350" cap="flat" cmpd="sng" algn="ctr">
+                      <a:solidFill>
+                        <a:srgbClr val="E4E1DC"/>
+                      </a:solidFill>
+                      <a:prstDash val="solid"/>
+                      <a:round/>
+                      <a:headEnd type="none" w="med" len="med"/>
+                      <a:tailEnd type="none" w="med" len="med"/>
+                    </a:lnB>
+                    <a:solidFill>
+                      <a:srgbClr val="FFFFFF"/>
+                    </a:solidFill>
+                  </a:tcPr>
+                </a:tc>
+                <a:tc>
+                  <a:txBody>
+                    <a:bodyPr/>
+                    <a:lstStyle/>
+                    <a:p>
+                      <a:pPr indent="0" marL="0">
+                        <a:buNone/>
+                      </a:pPr>
+                      <a:r>
+                        <a:rPr lang="en-US" sz="1200" b="1" dirty="0">
+                          <a:solidFill>
+                            <a:srgbClr val="222222"/>
+                          </a:solidFill>
+                          <a:latin typeface="Yu Gothic" pitchFamily="34" charset="0"/>
+                          <a:ea typeface="Yu Gothic" pitchFamily="34" charset="-122"/>
+                          <a:cs typeface="Yu Gothic" pitchFamily="34" charset="-120"/>
+                        </a:rPr>
+                        <a:t>EMARF for Owners</a:t>
+                      </a:r>
+                      <a:endParaRPr lang="en-US" sz="1200" dirty="0">
+                        <a:latin typeface="Yu Gothic" charset="0"/>
+                        <a:ea typeface="Yu Gothic" charset="0"/>
+                        <a:cs typeface="Yu Gothic" charset="0"/>
+                      </a:endParaRPr>
+                    </a:p>
+                  </a:txBody>
+                  <a:tcPr marL="101600" marR="101600" marT="38100" marB="38100" anchor="ctr">
+                    <a:lnL w="6350" cap="flat" cmpd="sng" algn="ctr">
+                      <a:solidFill>
+                        <a:srgbClr val="E4E1DC"/>
+                      </a:solidFill>
+                      <a:prstDash val="solid"/>
+                      <a:round/>
+                      <a:headEnd type="none" w="med" len="med"/>
+                      <a:tailEnd type="none" w="med" len="med"/>
+                    </a:lnL>
+                    <a:lnR w="6350" cap="flat" cmpd="sng" algn="ctr">
+                      <a:solidFill>
+                        <a:srgbClr val="E4E1DC"/>
+                      </a:solidFill>
+                      <a:prstDash val="solid"/>
+                      <a:round/>
+                      <a:headEnd type="none" w="med" len="med"/>
+                      <a:tailEnd type="none" w="med" len="med"/>
+                    </a:lnR>
+                    <a:lnT w="6350" cap="flat" cmpd="sng" algn="ctr">
+                      <a:solidFill>
+                        <a:srgbClr val="E4E1DC"/>
+                      </a:solidFill>
+                      <a:prstDash val="solid"/>
+                      <a:round/>
+                      <a:headEnd type="none" w="med" len="med"/>
+                      <a:tailEnd type="none" w="med" len="med"/>
+                    </a:lnT>
+                    <a:lnB w="6350" cap="flat" cmpd="sng" algn="ctr">
+                      <a:solidFill>
+                        <a:srgbClr val="E4E1DC"/>
+                      </a:solidFill>
+                      <a:prstDash val="solid"/>
+                      <a:round/>
+                      <a:headEnd type="none" w="med" len="med"/>
+                      <a:tailEnd type="none" w="med" len="med"/>
+                    </a:lnB>
+                    <a:solidFill>
+                      <a:srgbClr val="FFFFFF"/>
+                    </a:solidFill>
+                  </a:tcPr>
+                </a:tc>
+                <a:tc>
+                  <a:txBody>
+                    <a:bodyPr/>
+                    <a:lstStyle/>
+                    <a:p>
+                      <a:pPr indent="0" marL="0">
+                        <a:buNone/>
+                      </a:pPr>
+                      <a:endParaRPr lang="en-US" sz="1100" dirty="0">
+                        <a:latin typeface="Yu Gothic" charset="0"/>
+                        <a:ea typeface="Yu Gothic" charset="0"/>
+                        <a:cs typeface="Yu Gothic" charset="0"/>
+                      </a:endParaRPr>
+                    </a:p>
+                  </a:txBody>
+                  <a:tcPr marL="101600" marR="101600" marT="38100" marB="38100" anchor="ctr">
+                    <a:lnL w="6350" cap="flat" cmpd="sng" algn="ctr">
+                      <a:solidFill>
+                        <a:srgbClr val="E4E1DC"/>
+                      </a:solidFill>
+                      <a:prstDash val="solid"/>
+                      <a:round/>
+                      <a:headEnd type="none" w="med" len="med"/>
+                      <a:tailEnd type="none" w="med" len="med"/>
+                    </a:lnL>
+                    <a:lnR w="6350" cap="flat" cmpd="sng" algn="ctr">
+                      <a:solidFill>
+                        <a:srgbClr val="E4E1DC"/>
+                      </a:solidFill>
+                      <a:prstDash val="solid"/>
+                      <a:round/>
+                      <a:headEnd type="none" w="med" len="med"/>
+                      <a:tailEnd type="none" w="med" len="med"/>
+                    </a:lnR>
+                    <a:lnT w="6350" cap="flat" cmpd="sng" algn="ctr">
+                      <a:solidFill>
+                        <a:srgbClr val="E4E1DC"/>
+                      </a:solidFill>
+                      <a:prstDash val="solid"/>
+                      <a:round/>
+                      <a:headEnd type="none" w="med" len="med"/>
+                      <a:tailEnd type="none" w="med" len="med"/>
+                    </a:lnT>
+                    <a:lnB w="6350" cap="flat" cmpd="sng" algn="ctr">
+                      <a:solidFill>
+                        <a:srgbClr val="E4E1DC"/>
+                      </a:solidFill>
+                      <a:prstDash val="solid"/>
+                      <a:round/>
+                      <a:headEnd type="none" w="med" len="med"/>
+                      <a:tailEnd type="none" w="med" len="med"/>
+                    </a:lnB>
+                    <a:solidFill>
+                      <a:srgbClr val="FFFFFF"/>
+                    </a:solidFill>
+                  </a:tcPr>
+                </a:tc>
+              </a:tr>
+              <a:tr h="365760">
+                <a:tc>
+                  <a:txBody>
+                    <a:bodyPr/>
+                    <a:lstStyle/>
+                    <a:p>
+                      <a:pPr indent="0" marL="0">
+                        <a:buNone/>
+                      </a:pPr>
+                      <a:r>
+                        <a:rPr lang="en-US" sz="1200" b="1" dirty="0">
+                          <a:solidFill>
+                            <a:srgbClr val="B8772E"/>
+                          </a:solidFill>
+                          <a:latin typeface="Yu Gothic" pitchFamily="34" charset="0"/>
+                          <a:ea typeface="Yu Gothic" pitchFamily="34" charset="-122"/>
+                          <a:cs typeface="Yu Gothic" pitchFamily="34" charset="-120"/>
+                        </a:rPr>
+                        <a:t>PJ4</a:t>
+                      </a:r>
+                      <a:endParaRPr lang="en-US" sz="1200" dirty="0">
+                        <a:latin typeface="Yu Gothic" charset="0"/>
+                        <a:ea typeface="Yu Gothic" charset="0"/>
+                        <a:cs typeface="Yu Gothic" charset="0"/>
+                      </a:endParaRPr>
+                    </a:p>
+                  </a:txBody>
+                  <a:tcPr marL="101600" marR="101600" marT="38100" marB="38100" anchor="ctr">
+                    <a:lnL w="6350" cap="flat" cmpd="sng" algn="ctr">
+                      <a:solidFill>
+                        <a:srgbClr val="E4E1DC"/>
+                      </a:solidFill>
+                      <a:prstDash val="solid"/>
+                      <a:round/>
+                      <a:headEnd type="none" w="med" len="med"/>
+                      <a:tailEnd type="none" w="med" len="med"/>
+                    </a:lnL>
+                    <a:lnR w="6350" cap="flat" cmpd="sng" algn="ctr">
+                      <a:solidFill>
+                        <a:srgbClr val="E4E1DC"/>
+                      </a:solidFill>
+                      <a:prstDash val="solid"/>
+                      <a:round/>
+                      <a:headEnd type="none" w="med" len="med"/>
+                      <a:tailEnd type="none" w="med" len="med"/>
+                    </a:lnR>
+                    <a:lnT w="6350" cap="flat" cmpd="sng" algn="ctr">
+                      <a:solidFill>
+                        <a:srgbClr val="E4E1DC"/>
+                      </a:solidFill>
+                      <a:prstDash val="solid"/>
+                      <a:round/>
+                      <a:headEnd type="none" w="med" len="med"/>
+                      <a:tailEnd type="none" w="med" len="med"/>
+                    </a:lnT>
+                    <a:lnB w="6350" cap="flat" cmpd="sng" algn="ctr">
+                      <a:solidFill>
+                        <a:srgbClr val="E4E1DC"/>
+                      </a:solidFill>
+                      <a:prstDash val="solid"/>
+                      <a:round/>
+                      <a:headEnd type="none" w="med" len="med"/>
+                      <a:tailEnd type="none" w="med" len="med"/>
+                    </a:lnB>
+                    <a:solidFill>
+                      <a:srgbClr val="F7F2EA"/>
+                    </a:solidFill>
+                  </a:tcPr>
+                </a:tc>
+                <a:tc>
+                  <a:txBody>
+                    <a:bodyPr/>
+                    <a:lstStyle/>
+                    <a:p>
+                      <a:pPr indent="0" marL="0">
+                        <a:buNone/>
+                      </a:pPr>
+                      <a:r>
+                        <a:rPr lang="en-US" sz="1200" b="1" dirty="0">
+                          <a:solidFill>
+                            <a:srgbClr val="222222"/>
+                          </a:solidFill>
+                          <a:latin typeface="Yu Gothic" pitchFamily="34" charset="0"/>
+                          <a:ea typeface="Yu Gothic" pitchFamily="34" charset="-122"/>
+                          <a:cs typeface="Yu Gothic" pitchFamily="34" charset="-120"/>
+                        </a:rPr>
+                        <a:t>ヴィルダーズサクセスプラン（VSP）</a:t>
+                      </a:r>
+                      <a:endParaRPr lang="en-US" sz="1200" dirty="0">
+                        <a:latin typeface="Yu Gothic" charset="0"/>
+                        <a:ea typeface="Yu Gothic" charset="0"/>
+                        <a:cs typeface="Yu Gothic" charset="0"/>
+                      </a:endParaRPr>
+                    </a:p>
+                  </a:txBody>
+                  <a:tcPr marL="101600" marR="101600" marT="38100" marB="38100" anchor="ctr">
+                    <a:lnL w="6350" cap="flat" cmpd="sng" algn="ctr">
+                      <a:solidFill>
+                        <a:srgbClr val="E4E1DC"/>
+                      </a:solidFill>
+                      <a:prstDash val="solid"/>
+                      <a:round/>
+                      <a:headEnd type="none" w="med" len="med"/>
+                      <a:tailEnd type="none" w="med" len="med"/>
+                    </a:lnL>
+                    <a:lnR w="6350" cap="flat" cmpd="sng" algn="ctr">
+                      <a:solidFill>
+                        <a:srgbClr val="E4E1DC"/>
+                      </a:solidFill>
+                      <a:prstDash val="solid"/>
+                      <a:round/>
+                      <a:headEnd type="none" w="med" len="med"/>
+                      <a:tailEnd type="none" w="med" len="med"/>
+                    </a:lnR>
+                    <a:lnT w="6350" cap="flat" cmpd="sng" algn="ctr">
+                      <a:solidFill>
+                        <a:srgbClr val="E4E1DC"/>
+                      </a:solidFill>
+                      <a:prstDash val="solid"/>
+                      <a:round/>
+                      <a:headEnd type="none" w="med" len="med"/>
+                      <a:tailEnd type="none" w="med" len="med"/>
+                    </a:lnT>
+                    <a:lnB w="6350" cap="flat" cmpd="sng" algn="ctr">
+                      <a:solidFill>
+                        <a:srgbClr val="E4E1DC"/>
+                      </a:solidFill>
+                      <a:prstDash val="solid"/>
+                      <a:round/>
+                      <a:headEnd type="none" w="med" len="med"/>
+                      <a:tailEnd type="none" w="med" len="med"/>
+                    </a:lnB>
+                    <a:solidFill>
+                      <a:srgbClr val="F7F2EA"/>
+                    </a:solidFill>
+                  </a:tcPr>
+                </a:tc>
+                <a:tc>
+                  <a:txBody>
+                    <a:bodyPr/>
+                    <a:lstStyle/>
+                    <a:p>
+                      <a:pPr indent="0" marL="0">
+                        <a:buNone/>
+                      </a:pPr>
+                      <a:r>
+                        <a:rPr lang="en-US" sz="1100" dirty="0">
+                          <a:solidFill>
+                            <a:srgbClr val="B8772E"/>
+                          </a:solidFill>
+                          <a:latin typeface="Yu Gothic" pitchFamily="34" charset="0"/>
+                          <a:ea typeface="Yu Gothic" pitchFamily="34" charset="-122"/>
+                          <a:cs typeface="Yu Gothic" pitchFamily="34" charset="-120"/>
+                        </a:rPr>
+                        <a:t>活用オーナーの声を集める（コンセントファニチャー・三祐木材 等）</a:t>
+                      </a:r>
+                      <a:endParaRPr lang="en-US" sz="1100" dirty="0">
+                        <a:latin typeface="Yu Gothic" charset="0"/>
+                        <a:ea typeface="Yu Gothic" charset="0"/>
+                        <a:cs typeface="Yu Gothic" charset="0"/>
+                      </a:endParaRPr>
+                    </a:p>
+                  </a:txBody>
+                  <a:tcPr marL="101600" marR="101600" marT="38100" marB="38100" anchor="ctr">
+                    <a:lnL w="6350" cap="flat" cmpd="sng" algn="ctr">
+                      <a:solidFill>
+                        <a:srgbClr val="E4E1DC"/>
+                      </a:solidFill>
+                      <a:prstDash val="solid"/>
+                      <a:round/>
+                      <a:headEnd type="none" w="med" len="med"/>
+                      <a:tailEnd type="none" w="med" len="med"/>
+                    </a:lnL>
+                    <a:lnR w="6350" cap="flat" cmpd="sng" algn="ctr">
+                      <a:solidFill>
+                        <a:srgbClr val="E4E1DC"/>
+                      </a:solidFill>
+                      <a:prstDash val="solid"/>
+                      <a:round/>
+                      <a:headEnd type="none" w="med" len="med"/>
+                      <a:tailEnd type="none" w="med" len="med"/>
+                    </a:lnR>
+                    <a:lnT w="6350" cap="flat" cmpd="sng" algn="ctr">
+                      <a:solidFill>
+                        <a:srgbClr val="E4E1DC"/>
+                      </a:solidFill>
+                      <a:prstDash val="solid"/>
+                      <a:round/>
+                      <a:headEnd type="none" w="med" len="med"/>
+                      <a:tailEnd type="none" w="med" len="med"/>
+                    </a:lnT>
+                    <a:lnB w="6350" cap="flat" cmpd="sng" algn="ctr">
+                      <a:solidFill>
+                        <a:srgbClr val="E4E1DC"/>
+                      </a:solidFill>
+                      <a:prstDash val="solid"/>
+                      <a:round/>
+                      <a:headEnd type="none" w="med" len="med"/>
+                      <a:tailEnd type="none" w="med" len="med"/>
+                    </a:lnB>
+                    <a:solidFill>
+                      <a:srgbClr val="F7F2EA"/>
+                    </a:solidFill>
+                  </a:tcPr>
+                </a:tc>
+              </a:tr>
+              <a:tr h="365760">
+                <a:tc>
+                  <a:txBody>
+                    <a:bodyPr/>
+                    <a:lstStyle/>
+                    <a:p>
+                      <a:pPr indent="0" marL="0">
+                        <a:buNone/>
+                      </a:pPr>
+                      <a:r>
+                        <a:rPr lang="en-US" sz="1200" b="1" dirty="0">
+                          <a:solidFill>
+                            <a:srgbClr val="B8772E"/>
+                          </a:solidFill>
+                          <a:latin typeface="Yu Gothic" pitchFamily="34" charset="0"/>
+                          <a:ea typeface="Yu Gothic" pitchFamily="34" charset="-122"/>
+                          <a:cs typeface="Yu Gothic" pitchFamily="34" charset="-120"/>
+                        </a:rPr>
+                        <a:t>PJ5</a:t>
+                      </a:r>
+                      <a:endParaRPr lang="en-US" sz="1200" dirty="0">
+                        <a:latin typeface="Yu Gothic" charset="0"/>
+                        <a:ea typeface="Yu Gothic" charset="0"/>
+                        <a:cs typeface="Yu Gothic" charset="0"/>
+                      </a:endParaRPr>
+                    </a:p>
+                  </a:txBody>
+                  <a:tcPr marL="101600" marR="101600" marT="38100" marB="38100" anchor="ctr">
+                    <a:lnL w="6350" cap="flat" cmpd="sng" algn="ctr">
+                      <a:solidFill>
+                        <a:srgbClr val="E4E1DC"/>
+                      </a:solidFill>
+                      <a:prstDash val="solid"/>
+                      <a:round/>
+                      <a:headEnd type="none" w="med" len="med"/>
+                      <a:tailEnd type="none" w="med" len="med"/>
+                    </a:lnL>
+                    <a:lnR w="6350" cap="flat" cmpd="sng" algn="ctr">
+                      <a:solidFill>
+                        <a:srgbClr val="E4E1DC"/>
+                      </a:solidFill>
+                      <a:prstDash val="solid"/>
+                      <a:round/>
+                      <a:headEnd type="none" w="med" len="med"/>
+                      <a:tailEnd type="none" w="med" len="med"/>
+                    </a:lnR>
+                    <a:lnT w="6350" cap="flat" cmpd="sng" algn="ctr">
+                      <a:solidFill>
+                        <a:srgbClr val="E4E1DC"/>
+                      </a:solidFill>
+                      <a:prstDash val="solid"/>
+                      <a:round/>
+                      <a:headEnd type="none" w="med" len="med"/>
+                      <a:tailEnd type="none" w="med" len="med"/>
+                    </a:lnT>
+                    <a:lnB w="6350" cap="flat" cmpd="sng" algn="ctr">
+                      <a:solidFill>
+                        <a:srgbClr val="E4E1DC"/>
+                      </a:solidFill>
+                      <a:prstDash val="solid"/>
+                      <a:round/>
+                      <a:headEnd type="none" w="med" len="med"/>
+                      <a:tailEnd type="none" w="med" len="med"/>
+                    </a:lnB>
+                    <a:solidFill>
+                      <a:srgbClr val="FFFFFF"/>
+                    </a:solidFill>
+                  </a:tcPr>
+                </a:tc>
+                <a:tc>
+                  <a:txBody>
+                    <a:bodyPr/>
+                    <a:lstStyle/>
+                    <a:p>
+                      <a:pPr indent="0" marL="0">
+                        <a:buNone/>
+                      </a:pPr>
+                      <a:r>
+                        <a:rPr lang="en-US" sz="1200" b="1" dirty="0">
+                          <a:solidFill>
+                            <a:srgbClr val="222222"/>
+                          </a:solidFill>
+                          <a:latin typeface="Yu Gothic" pitchFamily="34" charset="0"/>
+                          <a:ea typeface="Yu Gothic" pitchFamily="34" charset="-122"/>
+                          <a:cs typeface="Yu Gothic" pitchFamily="34" charset="-120"/>
+                        </a:rPr>
+                        <a:t>Co-BUILD</a:t>
+                      </a:r>
+                      <a:endParaRPr lang="en-US" sz="1200" dirty="0">
+                        <a:latin typeface="Yu Gothic" charset="0"/>
+                        <a:ea typeface="Yu Gothic" charset="0"/>
+                        <a:cs typeface="Yu Gothic" charset="0"/>
+                      </a:endParaRPr>
+                    </a:p>
+                  </a:txBody>
+                  <a:tcPr marL="101600" marR="101600" marT="38100" marB="38100" anchor="ctr">
+                    <a:lnL w="6350" cap="flat" cmpd="sng" algn="ctr">
+                      <a:solidFill>
+                        <a:srgbClr val="E4E1DC"/>
+                      </a:solidFill>
+                      <a:prstDash val="solid"/>
+                      <a:round/>
+                      <a:headEnd type="none" w="med" len="med"/>
+                      <a:tailEnd type="none" w="med" len="med"/>
+                    </a:lnL>
+                    <a:lnR w="6350" cap="flat" cmpd="sng" algn="ctr">
+                      <a:solidFill>
+                        <a:srgbClr val="E4E1DC"/>
+                      </a:solidFill>
+                      <a:prstDash val="solid"/>
+                      <a:round/>
+                      <a:headEnd type="none" w="med" len="med"/>
+                      <a:tailEnd type="none" w="med" len="med"/>
+                    </a:lnR>
+                    <a:lnT w="6350" cap="flat" cmpd="sng" algn="ctr">
+                      <a:solidFill>
+                        <a:srgbClr val="E4E1DC"/>
+                      </a:solidFill>
+                      <a:prstDash val="solid"/>
+                      <a:round/>
+                      <a:headEnd type="none" w="med" len="med"/>
+                      <a:tailEnd type="none" w="med" len="med"/>
+                    </a:lnT>
+                    <a:lnB w="6350" cap="flat" cmpd="sng" algn="ctr">
+                      <a:solidFill>
+                        <a:srgbClr val="E4E1DC"/>
+                      </a:solidFill>
+                      <a:prstDash val="solid"/>
+                      <a:round/>
+                      <a:headEnd type="none" w="med" len="med"/>
+                      <a:tailEnd type="none" w="med" len="med"/>
+                    </a:lnB>
+                    <a:solidFill>
+                      <a:srgbClr val="FFFFFF"/>
+                    </a:solidFill>
+                  </a:tcPr>
+                </a:tc>
+                <a:tc>
+                  <a:txBody>
+                    <a:bodyPr/>
+                    <a:lstStyle/>
+                    <a:p>
+                      <a:pPr indent="0" marL="0">
+                        <a:buNone/>
+                      </a:pPr>
+                      <a:r>
+                        <a:rPr lang="en-US" sz="1100" dirty="0">
+                          <a:solidFill>
+                            <a:srgbClr val="B8772E"/>
+                          </a:solidFill>
+                          <a:latin typeface="Yu Gothic" pitchFamily="34" charset="0"/>
+                          <a:ea typeface="Yu Gothic" pitchFamily="34" charset="-122"/>
+                          <a:cs typeface="Yu Gothic" pitchFamily="34" charset="-120"/>
+                        </a:rPr>
+                        <a:t>要議論</a:t>
+                      </a:r>
+                      <a:endParaRPr lang="en-US" sz="1100" dirty="0">
+                        <a:latin typeface="Yu Gothic" charset="0"/>
+                        <a:ea typeface="Yu Gothic" charset="0"/>
+                        <a:cs typeface="Yu Gothic" charset="0"/>
+                      </a:endParaRPr>
+                    </a:p>
+                  </a:txBody>
+                  <a:tcPr marL="101600" marR="101600" marT="38100" marB="38100" anchor="ctr">
+                    <a:lnL w="6350" cap="flat" cmpd="sng" algn="ctr">
+                      <a:solidFill>
+                        <a:srgbClr val="E4E1DC"/>
+                      </a:solidFill>
+                      <a:prstDash val="solid"/>
+                      <a:round/>
+                      <a:headEnd type="none" w="med" len="med"/>
+                      <a:tailEnd type="none" w="med" len="med"/>
+                    </a:lnL>
+                    <a:lnR w="6350" cap="flat" cmpd="sng" algn="ctr">
+                      <a:solidFill>
+                        <a:srgbClr val="E4E1DC"/>
+                      </a:solidFill>
+                      <a:prstDash val="solid"/>
+                      <a:round/>
+                      <a:headEnd type="none" w="med" len="med"/>
+                      <a:tailEnd type="none" w="med" len="med"/>
+                    </a:lnR>
+                    <a:lnT w="6350" cap="flat" cmpd="sng" algn="ctr">
+                      <a:solidFill>
+                        <a:srgbClr val="E4E1DC"/>
+                      </a:solidFill>
+                      <a:prstDash val="solid"/>
+                      <a:round/>
+                      <a:headEnd type="none" w="med" len="med"/>
+                      <a:tailEnd type="none" w="med" len="med"/>
+                    </a:lnT>
+                    <a:lnB w="6350" cap="flat" cmpd="sng" algn="ctr">
+                      <a:solidFill>
+                        <a:srgbClr val="E4E1DC"/>
+                      </a:solidFill>
+                      <a:prstDash val="solid"/>
+                      <a:round/>
+                      <a:headEnd type="none" w="med" len="med"/>
+                      <a:tailEnd type="none" w="med" len="med"/>
+                    </a:lnB>
+                    <a:solidFill>
+                      <a:srgbClr val="FFFFFF"/>
+                    </a:solidFill>
+                  </a:tcPr>
+                </a:tc>
+              </a:tr>
+              <a:tr h="365760">
+                <a:tc>
+                  <a:txBody>
+                    <a:bodyPr/>
+                    <a:lstStyle/>
+                    <a:p>
+                      <a:pPr indent="0" marL="0">
+                        <a:buNone/>
+                      </a:pPr>
+                      <a:r>
+                        <a:rPr lang="en-US" sz="1200" b="1" dirty="0">
+                          <a:solidFill>
+                            <a:srgbClr val="B8772E"/>
+                          </a:solidFill>
+                          <a:latin typeface="Yu Gothic" pitchFamily="34" charset="0"/>
+                          <a:ea typeface="Yu Gothic" pitchFamily="34" charset="-122"/>
+                          <a:cs typeface="Yu Gothic" pitchFamily="34" charset="-120"/>
+                        </a:rPr>
+                        <a:t>PJ6</a:t>
+                      </a:r>
+                      <a:endParaRPr lang="en-US" sz="1200" dirty="0">
+                        <a:latin typeface="Yu Gothic" charset="0"/>
+                        <a:ea typeface="Yu Gothic" charset="0"/>
+                        <a:cs typeface="Yu Gothic" charset="0"/>
+                      </a:endParaRPr>
+                    </a:p>
+                  </a:txBody>
+                  <a:tcPr marL="101600" marR="101600" marT="38100" marB="38100" anchor="ctr">
+                    <a:lnL w="6350" cap="flat" cmpd="sng" algn="ctr">
+                      <a:solidFill>
+                        <a:srgbClr val="E4E1DC"/>
+                      </a:solidFill>
+                      <a:prstDash val="solid"/>
+                      <a:round/>
+                      <a:headEnd type="none" w="med" len="med"/>
+                      <a:tailEnd type="none" w="med" len="med"/>
+                    </a:lnL>
+                    <a:lnR w="6350" cap="flat" cmpd="sng" algn="ctr">
+                      <a:solidFill>
+                        <a:srgbClr val="E4E1DC"/>
+                      </a:solidFill>
+                      <a:prstDash val="solid"/>
+                      <a:round/>
+                      <a:headEnd type="none" w="med" len="med"/>
+                      <a:tailEnd type="none" w="med" len="med"/>
+                    </a:lnR>
+                    <a:lnT w="6350" cap="flat" cmpd="sng" algn="ctr">
+                      <a:solidFill>
+                        <a:srgbClr val="E4E1DC"/>
+                      </a:solidFill>
+                      <a:prstDash val="solid"/>
+                      <a:round/>
+                      <a:headEnd type="none" w="med" len="med"/>
+                      <a:tailEnd type="none" w="med" len="med"/>
+                    </a:lnT>
+                    <a:lnB w="6350" cap="flat" cmpd="sng" algn="ctr">
+                      <a:solidFill>
+                        <a:srgbClr val="E4E1DC"/>
+                      </a:solidFill>
+                      <a:prstDash val="solid"/>
+                      <a:round/>
+                      <a:headEnd type="none" w="med" len="med"/>
+                      <a:tailEnd type="none" w="med" len="med"/>
+                    </a:lnB>
+                    <a:solidFill>
+                      <a:srgbClr val="F7F2EA"/>
+                    </a:solidFill>
+                  </a:tcPr>
+                </a:tc>
+                <a:tc>
+                  <a:txBody>
+                    <a:bodyPr/>
+                    <a:lstStyle/>
+                    <a:p>
+                      <a:pPr indent="0" marL="0">
+                        <a:buNone/>
+                      </a:pPr>
+                      <a:r>
+                        <a:rPr lang="en-US" sz="1200" b="1" dirty="0">
+                          <a:solidFill>
+                            <a:srgbClr val="222222"/>
+                          </a:solidFill>
+                          <a:latin typeface="Yu Gothic" pitchFamily="34" charset="0"/>
+                          <a:ea typeface="Yu Gothic" pitchFamily="34" charset="-122"/>
+                          <a:cs typeface="Yu Gothic" pitchFamily="34" charset="-120"/>
+                        </a:rPr>
+                        <a:t>既存EMARF（プレカットサービス）</a:t>
+                      </a:r>
+                      <a:endParaRPr lang="en-US" sz="1200" dirty="0">
+                        <a:latin typeface="Yu Gothic" charset="0"/>
+                        <a:ea typeface="Yu Gothic" charset="0"/>
+                        <a:cs typeface="Yu Gothic" charset="0"/>
+                      </a:endParaRPr>
+                    </a:p>
+                  </a:txBody>
+                  <a:tcPr marL="101600" marR="101600" marT="38100" marB="38100" anchor="ctr">
+                    <a:lnL w="6350" cap="flat" cmpd="sng" algn="ctr">
+                      <a:solidFill>
+                        <a:srgbClr val="E4E1DC"/>
+                      </a:solidFill>
+                      <a:prstDash val="solid"/>
+                      <a:round/>
+                      <a:headEnd type="none" w="med" len="med"/>
+                      <a:tailEnd type="none" w="med" len="med"/>
+                    </a:lnL>
+                    <a:lnR w="6350" cap="flat" cmpd="sng" algn="ctr">
+                      <a:solidFill>
+                        <a:srgbClr val="E4E1DC"/>
+                      </a:solidFill>
+                      <a:prstDash val="solid"/>
+                      <a:round/>
+                      <a:headEnd type="none" w="med" len="med"/>
+                      <a:tailEnd type="none" w="med" len="med"/>
+                    </a:lnR>
+                    <a:lnT w="6350" cap="flat" cmpd="sng" algn="ctr">
+                      <a:solidFill>
+                        <a:srgbClr val="E4E1DC"/>
+                      </a:solidFill>
+                      <a:prstDash val="solid"/>
+                      <a:round/>
+                      <a:headEnd type="none" w="med" len="med"/>
+                      <a:tailEnd type="none" w="med" len="med"/>
+                    </a:lnT>
+                    <a:lnB w="6350" cap="flat" cmpd="sng" algn="ctr">
+                      <a:solidFill>
+                        <a:srgbClr val="E4E1DC"/>
+                      </a:solidFill>
+                      <a:prstDash val="solid"/>
+                      <a:round/>
+                      <a:headEnd type="none" w="med" len="med"/>
+                      <a:tailEnd type="none" w="med" len="med"/>
+                    </a:lnB>
+                    <a:solidFill>
+                      <a:srgbClr val="F7F2EA"/>
+                    </a:solidFill>
+                  </a:tcPr>
+                </a:tc>
+                <a:tc>
+                  <a:txBody>
+                    <a:bodyPr/>
+                    <a:lstStyle/>
+                    <a:p>
+                      <a:pPr indent="0" marL="0">
+                        <a:buNone/>
+                      </a:pPr>
+                      <a:r>
+                        <a:rPr lang="en-US" sz="1100" dirty="0">
+                          <a:solidFill>
+                            <a:srgbClr val="B8772E"/>
+                          </a:solidFill>
+                          <a:latin typeface="Yu Gothic" pitchFamily="34" charset="0"/>
+                          <a:ea typeface="Yu Gothic" pitchFamily="34" charset="-122"/>
+                          <a:cs typeface="Yu Gothic" pitchFamily="34" charset="-120"/>
+                        </a:rPr>
+                        <a:t>「EMARFとは」の再定義が必要</a:t>
+                      </a:r>
+                      <a:endParaRPr lang="en-US" sz="1100" dirty="0">
+                        <a:latin typeface="Yu Gothic" charset="0"/>
+                        <a:ea typeface="Yu Gothic" charset="0"/>
+                        <a:cs typeface="Yu Gothic" charset="0"/>
+                      </a:endParaRPr>
+                    </a:p>
+                  </a:txBody>
+                  <a:tcPr marL="101600" marR="101600" marT="38100" marB="38100" anchor="ctr">
+                    <a:lnL w="6350" cap="flat" cmpd="sng" algn="ctr">
+                      <a:solidFill>
+                        <a:srgbClr val="E4E1DC"/>
+                      </a:solidFill>
+                      <a:prstDash val="solid"/>
+                      <a:round/>
+                      <a:headEnd type="none" w="med" len="med"/>
+                      <a:tailEnd type="none" w="med" len="med"/>
+                    </a:lnL>
+                    <a:lnR w="6350" cap="flat" cmpd="sng" algn="ctr">
+                      <a:solidFill>
+                        <a:srgbClr val="E4E1DC"/>
+                      </a:solidFill>
+                      <a:prstDash val="solid"/>
+                      <a:round/>
+                      <a:headEnd type="none" w="med" len="med"/>
+                      <a:tailEnd type="none" w="med" len="med"/>
+                    </a:lnR>
+                    <a:lnT w="6350" cap="flat" cmpd="sng" algn="ctr">
+                      <a:solidFill>
+                        <a:srgbClr val="E4E1DC"/>
+                      </a:solidFill>
+                      <a:prstDash val="solid"/>
+                      <a:round/>
+                      <a:headEnd type="none" w="med" len="med"/>
+                      <a:tailEnd type="none" w="med" len="med"/>
+                    </a:lnT>
+                    <a:lnB w="6350" cap="flat" cmpd="sng" algn="ctr">
+                      <a:solidFill>
+                        <a:srgbClr val="E4E1DC"/>
+                      </a:solidFill>
+                      <a:prstDash val="solid"/>
+                      <a:round/>
+                      <a:headEnd type="none" w="med" len="med"/>
+                      <a:tailEnd type="none" w="med" len="med"/>
+                    </a:lnB>
+                    <a:solidFill>
+                      <a:srgbClr val="F7F2EA"/>
+                    </a:solidFill>
+                  </a:tcPr>
+                </a:tc>
+              </a:tr>
+              <a:tr h="365760">
+                <a:tc>
+                  <a:txBody>
+                    <a:bodyPr/>
+                    <a:lstStyle/>
+                    <a:p>
+                      <a:pPr indent="0" marL="0">
+                        <a:buNone/>
+                      </a:pPr>
+                      <a:r>
+                        <a:rPr lang="en-US" sz="1200" b="1" dirty="0">
+                          <a:solidFill>
+                            <a:srgbClr val="B8772E"/>
+                          </a:solidFill>
+                          <a:latin typeface="Yu Gothic" pitchFamily="34" charset="0"/>
+                          <a:ea typeface="Yu Gothic" pitchFamily="34" charset="-122"/>
+                          <a:cs typeface="Yu Gothic" pitchFamily="34" charset="-120"/>
+                        </a:rPr>
+                        <a:t>PJ7</a:t>
+                      </a:r>
+                      <a:endParaRPr lang="en-US" sz="1200" dirty="0">
+                        <a:latin typeface="Yu Gothic" charset="0"/>
+                        <a:ea typeface="Yu Gothic" charset="0"/>
+                        <a:cs typeface="Yu Gothic" charset="0"/>
+                      </a:endParaRPr>
+                    </a:p>
+                  </a:txBody>
+                  <a:tcPr marL="101600" marR="101600" marT="38100" marB="38100" anchor="ctr">
+                    <a:lnL w="6350" cap="flat" cmpd="sng" algn="ctr">
+                      <a:solidFill>
+                        <a:srgbClr val="E4E1DC"/>
+                      </a:solidFill>
+                      <a:prstDash val="solid"/>
+                      <a:round/>
+                      <a:headEnd type="none" w="med" len="med"/>
+                      <a:tailEnd type="none" w="med" len="med"/>
+                    </a:lnL>
+                    <a:lnR w="6350" cap="flat" cmpd="sng" algn="ctr">
+                      <a:solidFill>
+                        <a:srgbClr val="E4E1DC"/>
+                      </a:solidFill>
+                      <a:prstDash val="solid"/>
+                      <a:round/>
+                      <a:headEnd type="none" w="med" len="med"/>
+                      <a:tailEnd type="none" w="med" len="med"/>
+                    </a:lnR>
+                    <a:lnT w="6350" cap="flat" cmpd="sng" algn="ctr">
+                      <a:solidFill>
+                        <a:srgbClr val="E4E1DC"/>
+                      </a:solidFill>
+                      <a:prstDash val="solid"/>
+                      <a:round/>
+                      <a:headEnd type="none" w="med" len="med"/>
+                      <a:tailEnd type="none" w="med" len="med"/>
+                    </a:lnT>
+                    <a:lnB w="6350" cap="flat" cmpd="sng" algn="ctr">
+                      <a:solidFill>
+                        <a:srgbClr val="E4E1DC"/>
+                      </a:solidFill>
+                      <a:prstDash val="solid"/>
+                      <a:round/>
+                      <a:headEnd type="none" w="med" len="med"/>
+                      <a:tailEnd type="none" w="med" len="med"/>
+                    </a:lnB>
+                    <a:solidFill>
+                      <a:srgbClr val="FFFFFF"/>
+                    </a:solidFill>
+                  </a:tcPr>
+                </a:tc>
+                <a:tc>
+                  <a:txBody>
+                    <a:bodyPr/>
+                    <a:lstStyle/>
+                    <a:p>
+                      <a:pPr indent="0" marL="0">
+                        <a:buNone/>
+                      </a:pPr>
+                      <a:r>
+                        <a:rPr lang="en-US" sz="1200" b="1" dirty="0">
+                          <a:solidFill>
+                            <a:srgbClr val="222222"/>
+                          </a:solidFill>
+                          <a:latin typeface="Yu Gothic" pitchFamily="34" charset="0"/>
+                          <a:ea typeface="Yu Gothic" pitchFamily="34" charset="-122"/>
+                          <a:cs typeface="Yu Gothic" pitchFamily="34" charset="-120"/>
+                        </a:rPr>
+                        <a:t>Morimobi 岡崎</a:t>
+                      </a:r>
+                      <a:endParaRPr lang="en-US" sz="1200" dirty="0">
+                        <a:latin typeface="Yu Gothic" charset="0"/>
+                        <a:ea typeface="Yu Gothic" charset="0"/>
+                        <a:cs typeface="Yu Gothic" charset="0"/>
+                      </a:endParaRPr>
+                    </a:p>
+                  </a:txBody>
+                  <a:tcPr marL="101600" marR="101600" marT="38100" marB="38100" anchor="ctr">
+                    <a:lnL w="6350" cap="flat" cmpd="sng" algn="ctr">
+                      <a:solidFill>
+                        <a:srgbClr val="E4E1DC"/>
+                      </a:solidFill>
+                      <a:prstDash val="solid"/>
+                      <a:round/>
+                      <a:headEnd type="none" w="med" len="med"/>
+                      <a:tailEnd type="none" w="med" len="med"/>
+                    </a:lnL>
+                    <a:lnR w="6350" cap="flat" cmpd="sng" algn="ctr">
+                      <a:solidFill>
+                        <a:srgbClr val="E4E1DC"/>
+                      </a:solidFill>
+                      <a:prstDash val="solid"/>
+                      <a:round/>
+                      <a:headEnd type="none" w="med" len="med"/>
+                      <a:tailEnd type="none" w="med" len="med"/>
+                    </a:lnR>
+                    <a:lnT w="6350" cap="flat" cmpd="sng" algn="ctr">
+                      <a:solidFill>
+                        <a:srgbClr val="E4E1DC"/>
+                      </a:solidFill>
+                      <a:prstDash val="solid"/>
+                      <a:round/>
+                      <a:headEnd type="none" w="med" len="med"/>
+                      <a:tailEnd type="none" w="med" len="med"/>
+                    </a:lnT>
+                    <a:lnB w="6350" cap="flat" cmpd="sng" algn="ctr">
+                      <a:solidFill>
+                        <a:srgbClr val="E4E1DC"/>
+                      </a:solidFill>
+                      <a:prstDash val="solid"/>
+                      <a:round/>
+                      <a:headEnd type="none" w="med" len="med"/>
+                      <a:tailEnd type="none" w="med" len="med"/>
+                    </a:lnB>
+                    <a:solidFill>
+                      <a:srgbClr val="FFFFFF"/>
+                    </a:solidFill>
+                  </a:tcPr>
+                </a:tc>
+                <a:tc>
+                  <a:txBody>
+                    <a:bodyPr/>
+                    <a:lstStyle/>
+                    <a:p>
+                      <a:pPr indent="0" marL="0">
+                        <a:buNone/>
+                      </a:pPr>
+                      <a:endParaRPr lang="en-US" sz="1100" dirty="0">
+                        <a:latin typeface="Yu Gothic" charset="0"/>
+                        <a:ea typeface="Yu Gothic" charset="0"/>
+                        <a:cs typeface="Yu Gothic" charset="0"/>
+                      </a:endParaRPr>
+                    </a:p>
+                  </a:txBody>
+                  <a:tcPr marL="101600" marR="101600" marT="38100" marB="38100" anchor="ctr">
+                    <a:lnL w="6350" cap="flat" cmpd="sng" algn="ctr">
+                      <a:solidFill>
+                        <a:srgbClr val="E4E1DC"/>
+                      </a:solidFill>
+                      <a:prstDash val="solid"/>
+                      <a:round/>
+                      <a:headEnd type="none" w="med" len="med"/>
+                      <a:tailEnd type="none" w="med" len="med"/>
+                    </a:lnL>
+                    <a:lnR w="6350" cap="flat" cmpd="sng" algn="ctr">
+                      <a:solidFill>
+                        <a:srgbClr val="E4E1DC"/>
+                      </a:solidFill>
+                      <a:prstDash val="solid"/>
+                      <a:round/>
+                      <a:headEnd type="none" w="med" len="med"/>
+                      <a:tailEnd type="none" w="med" len="med"/>
+                    </a:lnR>
+                    <a:lnT w="6350" cap="flat" cmpd="sng" algn="ctr">
+                      <a:solidFill>
+                        <a:srgbClr val="E4E1DC"/>
+                      </a:solidFill>
+                      <a:prstDash val="solid"/>
+                      <a:round/>
+                      <a:headEnd type="none" w="med" len="med"/>
+                      <a:tailEnd type="none" w="med" len="med"/>
+                    </a:lnT>
+                    <a:lnB w="6350" cap="flat" cmpd="sng" algn="ctr">
+                      <a:solidFill>
+                        <a:srgbClr val="E4E1DC"/>
+                      </a:solidFill>
+                      <a:prstDash val="solid"/>
+                      <a:round/>
+                      <a:headEnd type="none" w="med" len="med"/>
+                      <a:tailEnd type="none" w="med" len="med"/>
+                    </a:lnB>
+                    <a:solidFill>
+                      <a:srgbClr val="FFFFFF"/>
+                    </a:solidFill>
+                  </a:tcPr>
+                </a:tc>
+              </a:tr>
+              <a:tr h="365760">
+                <a:tc>
+                  <a:txBody>
+                    <a:bodyPr/>
+                    <a:lstStyle/>
+                    <a:p>
+                      <a:pPr indent="0" marL="0">
+                        <a:buNone/>
+                      </a:pPr>
+                      <a:r>
+                        <a:rPr lang="en-US" sz="1200" b="1" dirty="0">
+                          <a:solidFill>
+                            <a:srgbClr val="B8772E"/>
+                          </a:solidFill>
+                          <a:latin typeface="Yu Gothic" pitchFamily="34" charset="0"/>
+                          <a:ea typeface="Yu Gothic" pitchFamily="34" charset="-122"/>
+                          <a:cs typeface="Yu Gothic" pitchFamily="34" charset="-120"/>
+                        </a:rPr>
+                        <a:t>PJ8</a:t>
+                      </a:r>
+                      <a:endParaRPr lang="en-US" sz="1200" dirty="0">
+                        <a:latin typeface="Yu Gothic" charset="0"/>
+                        <a:ea typeface="Yu Gothic" charset="0"/>
+                        <a:cs typeface="Yu Gothic" charset="0"/>
+                      </a:endParaRPr>
+                    </a:p>
+                  </a:txBody>
+                  <a:tcPr marL="101600" marR="101600" marT="38100" marB="38100" anchor="ctr">
+                    <a:lnL w="6350" cap="flat" cmpd="sng" algn="ctr">
+                      <a:solidFill>
+                        <a:srgbClr val="E4E1DC"/>
+                      </a:solidFill>
+                      <a:prstDash val="solid"/>
+                      <a:round/>
+                      <a:headEnd type="none" w="med" len="med"/>
+                      <a:tailEnd type="none" w="med" len="med"/>
+                    </a:lnL>
+                    <a:lnR w="6350" cap="flat" cmpd="sng" algn="ctr">
+                      <a:solidFill>
+                        <a:srgbClr val="E4E1DC"/>
+                      </a:solidFill>
+                      <a:prstDash val="solid"/>
+                      <a:round/>
+                      <a:headEnd type="none" w="med" len="med"/>
+                      <a:tailEnd type="none" w="med" len="med"/>
+                    </a:lnR>
+                    <a:lnT w="6350" cap="flat" cmpd="sng" algn="ctr">
+                      <a:solidFill>
+                        <a:srgbClr val="E4E1DC"/>
+                      </a:solidFill>
+                      <a:prstDash val="solid"/>
+                      <a:round/>
+                      <a:headEnd type="none" w="med" len="med"/>
+                      <a:tailEnd type="none" w="med" len="med"/>
+                    </a:lnT>
+                    <a:lnB w="6350" cap="flat" cmpd="sng" algn="ctr">
+                      <a:solidFill>
+                        <a:srgbClr val="E4E1DC"/>
+                      </a:solidFill>
+                      <a:prstDash val="solid"/>
+                      <a:round/>
+                      <a:headEnd type="none" w="med" len="med"/>
+                      <a:tailEnd type="none" w="med" len="med"/>
+                    </a:lnB>
+                    <a:solidFill>
+                      <a:srgbClr val="F7F2EA"/>
+                    </a:solidFill>
+                  </a:tcPr>
+                </a:tc>
+                <a:tc>
+                  <a:txBody>
+                    <a:bodyPr/>
+                    <a:lstStyle/>
+                    <a:p>
+                      <a:pPr indent="0" marL="0">
+                        <a:buNone/>
+                      </a:pPr>
+                      <a:r>
+                        <a:rPr lang="en-US" sz="1200" b="1" dirty="0">
+                          <a:solidFill>
+                            <a:srgbClr val="222222"/>
+                          </a:solidFill>
+                          <a:latin typeface="Yu Gothic" pitchFamily="34" charset="0"/>
+                          <a:ea typeface="Yu Gothic" pitchFamily="34" charset="-122"/>
+                          <a:cs typeface="Yu Gothic" pitchFamily="34" charset="-120"/>
+                        </a:rPr>
+                        <a:t>久米製材</a:t>
+                      </a:r>
+                      <a:endParaRPr lang="en-US" sz="1200" dirty="0">
+                        <a:latin typeface="Yu Gothic" charset="0"/>
+                        <a:ea typeface="Yu Gothic" charset="0"/>
+                        <a:cs typeface="Yu Gothic" charset="0"/>
+                      </a:endParaRPr>
+                    </a:p>
+                  </a:txBody>
+                  <a:tcPr marL="101600" marR="101600" marT="38100" marB="38100" anchor="ctr">
+                    <a:lnL w="6350" cap="flat" cmpd="sng" algn="ctr">
+                      <a:solidFill>
+                        <a:srgbClr val="E4E1DC"/>
+                      </a:solidFill>
+                      <a:prstDash val="solid"/>
+                      <a:round/>
+                      <a:headEnd type="none" w="med" len="med"/>
+                      <a:tailEnd type="none" w="med" len="med"/>
+                    </a:lnL>
+                    <a:lnR w="6350" cap="flat" cmpd="sng" algn="ctr">
+                      <a:solidFill>
+                        <a:srgbClr val="E4E1DC"/>
+                      </a:solidFill>
+                      <a:prstDash val="solid"/>
+                      <a:round/>
+                      <a:headEnd type="none" w="med" len="med"/>
+                      <a:tailEnd type="none" w="med" len="med"/>
+                    </a:lnR>
+                    <a:lnT w="6350" cap="flat" cmpd="sng" algn="ctr">
+                      <a:solidFill>
+                        <a:srgbClr val="E4E1DC"/>
+                      </a:solidFill>
+                      <a:prstDash val="solid"/>
+                      <a:round/>
+                      <a:headEnd type="none" w="med" len="med"/>
+                      <a:tailEnd type="none" w="med" len="med"/>
+                    </a:lnT>
+                    <a:lnB w="6350" cap="flat" cmpd="sng" algn="ctr">
+                      <a:solidFill>
+                        <a:srgbClr val="E4E1DC"/>
+                      </a:solidFill>
+                      <a:prstDash val="solid"/>
+                      <a:round/>
+                      <a:headEnd type="none" w="med" len="med"/>
+                      <a:tailEnd type="none" w="med" len="med"/>
+                    </a:lnB>
+                    <a:solidFill>
+                      <a:srgbClr val="F7F2EA"/>
+                    </a:solidFill>
+                  </a:tcPr>
+                </a:tc>
+                <a:tc>
+                  <a:txBody>
+                    <a:bodyPr/>
+                    <a:lstStyle/>
+                    <a:p>
+                      <a:pPr indent="0" marL="0">
+                        <a:buNone/>
+                      </a:pPr>
+                      <a:r>
+                        <a:rPr lang="en-US" sz="1100" dirty="0">
+                          <a:solidFill>
+                            <a:srgbClr val="B8772E"/>
+                          </a:solidFill>
+                          <a:latin typeface="Yu Gothic" pitchFamily="34" charset="0"/>
+                          <a:ea typeface="Yu Gothic" pitchFamily="34" charset="-122"/>
+                          <a:cs typeface="Yu Gothic" pitchFamily="34" charset="-120"/>
+                        </a:rPr>
+                        <a:t>候補（検討中）</a:t>
+                      </a:r>
+                      <a:endParaRPr lang="en-US" sz="1100" dirty="0">
+                        <a:latin typeface="Yu Gothic" charset="0"/>
+                        <a:ea typeface="Yu Gothic" charset="0"/>
+                        <a:cs typeface="Yu Gothic" charset="0"/>
+                      </a:endParaRPr>
+                    </a:p>
+                  </a:txBody>
+                  <a:tcPr marL="101600" marR="101600" marT="38100" marB="38100" anchor="ctr">
+                    <a:lnL w="6350" cap="flat" cmpd="sng" algn="ctr">
+                      <a:solidFill>
+                        <a:srgbClr val="E4E1DC"/>
+                      </a:solidFill>
+                      <a:prstDash val="solid"/>
+                      <a:round/>
+                      <a:headEnd type="none" w="med" len="med"/>
+                      <a:tailEnd type="none" w="med" len="med"/>
+                    </a:lnL>
+                    <a:lnR w="6350" cap="flat" cmpd="sng" algn="ctr">
+                      <a:solidFill>
+                        <a:srgbClr val="E4E1DC"/>
+                      </a:solidFill>
+                      <a:prstDash val="solid"/>
+                      <a:round/>
+                      <a:headEnd type="none" w="med" len="med"/>
+                      <a:tailEnd type="none" w="med" len="med"/>
+                    </a:lnR>
+                    <a:lnT w="6350" cap="flat" cmpd="sng" algn="ctr">
+                      <a:solidFill>
+                        <a:srgbClr val="E4E1DC"/>
+                      </a:solidFill>
+                      <a:prstDash val="solid"/>
+                      <a:round/>
+                      <a:headEnd type="none" w="med" len="med"/>
+                      <a:tailEnd type="none" w="med" len="med"/>
+                    </a:lnT>
+                    <a:lnB w="6350" cap="flat" cmpd="sng" algn="ctr">
+                      <a:solidFill>
+                        <a:srgbClr val="E4E1DC"/>
+                      </a:solidFill>
+                      <a:prstDash val="solid"/>
+                      <a:round/>
+                      <a:headEnd type="none" w="med" len="med"/>
+                      <a:tailEnd type="none" w="med" len="med"/>
+                    </a:lnB>
+                    <a:solidFill>
+                      <a:srgbClr val="F7F2EA"/>
+                    </a:solidFill>
+                  </a:tcPr>
+                </a:tc>
+              </a:tr>
+              <a:tr h="365760">
+                <a:tc>
+                  <a:txBody>
+                    <a:bodyPr/>
+                    <a:lstStyle/>
+                    <a:p>
+                      <a:pPr indent="0" marL="0">
+                        <a:buNone/>
+                      </a:pPr>
+                      <a:r>
+                        <a:rPr lang="en-US" sz="1200" b="1" dirty="0">
+                          <a:solidFill>
+                            <a:srgbClr val="B8772E"/>
+                          </a:solidFill>
+                          <a:latin typeface="Yu Gothic" pitchFamily="34" charset="0"/>
+                          <a:ea typeface="Yu Gothic" pitchFamily="34" charset="-122"/>
+                          <a:cs typeface="Yu Gothic" pitchFamily="34" charset="-120"/>
+                        </a:rPr>
+                        <a:t>PJ9</a:t>
+                      </a:r>
+                      <a:endParaRPr lang="en-US" sz="1200" dirty="0">
+                        <a:latin typeface="Yu Gothic" charset="0"/>
+                        <a:ea typeface="Yu Gothic" charset="0"/>
+                        <a:cs typeface="Yu Gothic" charset="0"/>
+                      </a:endParaRPr>
+                    </a:p>
+                  </a:txBody>
+                  <a:tcPr marL="101600" marR="101600" marT="38100" marB="38100" anchor="ctr">
+                    <a:lnL w="6350" cap="flat" cmpd="sng" algn="ctr">
+                      <a:solidFill>
+                        <a:srgbClr val="E4E1DC"/>
+                      </a:solidFill>
+                      <a:prstDash val="solid"/>
+                      <a:round/>
+                      <a:headEnd type="none" w="med" len="med"/>
+                      <a:tailEnd type="none" w="med" len="med"/>
+                    </a:lnL>
+                    <a:lnR w="6350" cap="flat" cmpd="sng" algn="ctr">
+                      <a:solidFill>
+                        <a:srgbClr val="E4E1DC"/>
+                      </a:solidFill>
+                      <a:prstDash val="solid"/>
+                      <a:round/>
+                      <a:headEnd type="none" w="med" len="med"/>
+                      <a:tailEnd type="none" w="med" len="med"/>
+                    </a:lnR>
+                    <a:lnT w="6350" cap="flat" cmpd="sng" algn="ctr">
+                      <a:solidFill>
+                        <a:srgbClr val="E4E1DC"/>
+                      </a:solidFill>
+                      <a:prstDash val="solid"/>
+                      <a:round/>
+                      <a:headEnd type="none" w="med" len="med"/>
+                      <a:tailEnd type="none" w="med" len="med"/>
+                    </a:lnT>
+                    <a:lnB w="6350" cap="flat" cmpd="sng" algn="ctr">
+                      <a:solidFill>
+                        <a:srgbClr val="E4E1DC"/>
+                      </a:solidFill>
+                      <a:prstDash val="solid"/>
+                      <a:round/>
+                      <a:headEnd type="none" w="med" len="med"/>
+                      <a:tailEnd type="none" w="med" len="med"/>
+                    </a:lnB>
+                    <a:solidFill>
+                      <a:srgbClr val="FFFFFF"/>
+                    </a:solidFill>
+                  </a:tcPr>
+                </a:tc>
+                <a:tc>
+                  <a:txBody>
+                    <a:bodyPr/>
+                    <a:lstStyle/>
+                    <a:p>
+                      <a:pPr indent="0" marL="0">
+                        <a:buNone/>
+                      </a:pPr>
+                      <a:r>
+                        <a:rPr lang="en-US" sz="1200" b="1" dirty="0">
+                          <a:solidFill>
+                            <a:srgbClr val="222222"/>
+                          </a:solidFill>
+                          <a:latin typeface="Yu Gothic" pitchFamily="34" charset="0"/>
+                          <a:ea typeface="Yu Gothic" pitchFamily="34" charset="-122"/>
+                          <a:cs typeface="Yu Gothic" pitchFamily="34" charset="-120"/>
+                        </a:rPr>
+                        <a:t>松川</a:t>
+                      </a:r>
+                      <a:endParaRPr lang="en-US" sz="1200" dirty="0">
+                        <a:latin typeface="Yu Gothic" charset="0"/>
+                        <a:ea typeface="Yu Gothic" charset="0"/>
+                        <a:cs typeface="Yu Gothic" charset="0"/>
+                      </a:endParaRPr>
+                    </a:p>
+                  </a:txBody>
+                  <a:tcPr marL="101600" marR="101600" marT="38100" marB="38100" anchor="ctr">
+                    <a:lnL w="6350" cap="flat" cmpd="sng" algn="ctr">
+                      <a:solidFill>
+                        <a:srgbClr val="E4E1DC"/>
+                      </a:solidFill>
+                      <a:prstDash val="solid"/>
+                      <a:round/>
+                      <a:headEnd type="none" w="med" len="med"/>
+                      <a:tailEnd type="none" w="med" len="med"/>
+                    </a:lnL>
+                    <a:lnR w="6350" cap="flat" cmpd="sng" algn="ctr">
+                      <a:solidFill>
+                        <a:srgbClr val="E4E1DC"/>
+                      </a:solidFill>
+                      <a:prstDash val="solid"/>
+                      <a:round/>
+                      <a:headEnd type="none" w="med" len="med"/>
+                      <a:tailEnd type="none" w="med" len="med"/>
+                    </a:lnR>
+                    <a:lnT w="6350" cap="flat" cmpd="sng" algn="ctr">
+                      <a:solidFill>
+                        <a:srgbClr val="E4E1DC"/>
+                      </a:solidFill>
+                      <a:prstDash val="solid"/>
+                      <a:round/>
+                      <a:headEnd type="none" w="med" len="med"/>
+                      <a:tailEnd type="none" w="med" len="med"/>
+                    </a:lnT>
+                    <a:lnB w="6350" cap="flat" cmpd="sng" algn="ctr">
+                      <a:solidFill>
+                        <a:srgbClr val="E4E1DC"/>
+                      </a:solidFill>
+                      <a:prstDash val="solid"/>
+                      <a:round/>
+                      <a:headEnd type="none" w="med" len="med"/>
+                      <a:tailEnd type="none" w="med" len="med"/>
+                    </a:lnB>
+                    <a:solidFill>
+                      <a:srgbClr val="FFFFFF"/>
+                    </a:solidFill>
+                  </a:tcPr>
+                </a:tc>
+                <a:tc>
+                  <a:txBody>
+                    <a:bodyPr/>
+                    <a:lstStyle/>
+                    <a:p>
+                      <a:pPr indent="0" marL="0">
+                        <a:buNone/>
+                      </a:pPr>
+                      <a:r>
+                        <a:rPr lang="en-US" sz="1100" dirty="0">
+                          <a:solidFill>
+                            <a:srgbClr val="B8772E"/>
+                          </a:solidFill>
+                          <a:latin typeface="Yu Gothic" pitchFamily="34" charset="0"/>
+                          <a:ea typeface="Yu Gothic" pitchFamily="34" charset="-122"/>
+                          <a:cs typeface="Yu Gothic" pitchFamily="34" charset="-120"/>
+                        </a:rPr>
+                        <a:t>候補（検討中）</a:t>
+                      </a:r>
+                      <a:endParaRPr lang="en-US" sz="1100" dirty="0">
+                        <a:latin typeface="Yu Gothic" charset="0"/>
+                        <a:ea typeface="Yu Gothic" charset="0"/>
+                        <a:cs typeface="Yu Gothic" charset="0"/>
+                      </a:endParaRPr>
+                    </a:p>
+                  </a:txBody>
+                  <a:tcPr marL="101600" marR="101600" marT="38100" marB="38100" anchor="ctr">
+                    <a:lnL w="6350" cap="flat" cmpd="sng" algn="ctr">
+                      <a:solidFill>
+                        <a:srgbClr val="E4E1DC"/>
+                      </a:solidFill>
+                      <a:prstDash val="solid"/>
+                      <a:round/>
+                      <a:headEnd type="none" w="med" len="med"/>
+                      <a:tailEnd type="none" w="med" len="med"/>
+                    </a:lnL>
+                    <a:lnR w="6350" cap="flat" cmpd="sng" algn="ctr">
+                      <a:solidFill>
+                        <a:srgbClr val="E4E1DC"/>
+                      </a:solidFill>
+                      <a:prstDash val="solid"/>
+                      <a:round/>
+                      <a:headEnd type="none" w="med" len="med"/>
+                      <a:tailEnd type="none" w="med" len="med"/>
+                    </a:lnR>
+                    <a:lnT w="6350" cap="flat" cmpd="sng" algn="ctr">
+                      <a:solidFill>
+                        <a:srgbClr val="E4E1DC"/>
+                      </a:solidFill>
+                      <a:prstDash val="solid"/>
+                      <a:round/>
+                      <a:headEnd type="none" w="med" len="med"/>
+                      <a:tailEnd type="none" w="med" len="med"/>
+                    </a:lnT>
+                    <a:lnB w="6350" cap="flat" cmpd="sng" algn="ctr">
+                      <a:solidFill>
+                        <a:srgbClr val="E4E1DC"/>
+                      </a:solidFill>
+                      <a:prstDash val="solid"/>
+                      <a:round/>
+                      <a:headEnd type="none" w="med" len="med"/>
+                      <a:tailEnd type="none" w="med" len="med"/>
+                    </a:lnB>
+                    <a:solidFill>
+                      <a:srgbClr val="FFFFFF"/>
+                    </a:solidFill>
+                  </a:tcPr>
+                </a:tc>
+              </a:tr>
+            </a:tbl>
+          </a:graphicData>
+        </a:graphic>
+      </p:graphicFrame>
+      <p:sp>
+        <p:nvSpPr>
+          <p:cNvPr id="7" name="Text 4"/>
+          <p:cNvSpPr/>
+          <p:nvPr/>
+        </p:nvSpPr>
+        <p:spPr>
+          <a:xfrm>
+            <a:off x="841248" y="6400800"/>
+            <a:ext cx="7315200" cy="274320"/>
+          </a:xfrm>
+          <a:prstGeom prst="rect">
+            <a:avLst/>
+          </a:prstGeom>
+          <a:noFill/>
+          <a:ln/>
+        </p:spPr>
+        <p:txBody>
+          <a:bodyPr wrap="square" lIns="0" tIns="0" rIns="0" bIns="0" rtlCol="0" anchor="t"/>
+          <a:lstStyle/>
+          <a:p>
+            <a:pPr indent="0" marL="0">
+              <a:buNone/>
+            </a:pPr>
+            <a:r>
+              <a:rPr lang="en-US" sz="900" dirty="0">
+                <a:solidFill>
+                  <a:srgbClr val="A8A8A8"/>
+                </a:solidFill>
+                <a:latin typeface="Yu Gothic" pitchFamily="34" charset="0"/>
+                <a:ea typeface="Yu Gothic" pitchFamily="34" charset="-122"/>
+                <a:cs typeface="Yu Gothic" pitchFamily="34" charset="-120"/>
+              </a:rPr>
+              <a:t>Incubation Team OKR ・ リーダー定例 2026-06-28</a:t>
+            </a:r>
+            <a:endParaRPr lang="en-US" sz="900" dirty="0"/>
+          </a:p>
+        </p:txBody>
+      </p:sp>
+      <p:sp>
+        <p:nvSpPr>
+          <p:cNvPr id="8" name="Text 5"/>
+          <p:cNvSpPr/>
+          <p:nvPr/>
+        </p:nvSpPr>
+        <p:spPr>
+          <a:xfrm>
+            <a:off x="10436047" y="6400800"/>
+            <a:ext cx="914400" cy="274320"/>
+          </a:xfrm>
+          <a:prstGeom prst="rect">
+            <a:avLst/>
+          </a:prstGeom>
+          <a:noFill/>
+          <a:ln/>
+        </p:spPr>
+        <p:txBody>
+          <a:bodyPr wrap="square" lIns="0" tIns="0" rIns="0" bIns="0" rtlCol="0" anchor="t"/>
+          <a:lstStyle/>
+          <a:p>
+            <a:pPr algn="r" indent="0" marL="0">
+              <a:buNone/>
+            </a:pPr>
+            <a:r>
+              <a:rPr lang="en-US" sz="900" dirty="0">
+                <a:solidFill>
+                  <a:srgbClr val="A8A8A8"/>
+                </a:solidFill>
+                <a:latin typeface="Yu Gothic" pitchFamily="34" charset="0"/>
+                <a:ea typeface="Yu Gothic" pitchFamily="34" charset="-122"/>
+                <a:cs typeface="Yu Gothic" pitchFamily="34" charset="-120"/>
+              </a:rPr>
+              <a:t>14</a:t>
+            </a:r>
+            <a:endParaRPr lang="en-US" sz="900" dirty="0"/>
+          </a:p>
+        </p:txBody>
+      </p:sp>
+    </p:spTree>
+  </p:cSld>
+  <p:clrMapOvr>
+    <a:masterClrMapping/>
+  </p:clrMapOvr>
+</p:sld>
+</file>
+
 <file path=ppt/slides/slide2.xml><?xml version="1.0" encoding="utf-8"?>
 <p:sld xmlns:a="http://schemas.openxmlformats.org/drawingml/2006/main" xmlns:r="http://schemas.openxmlformats.org/officeDocument/2006/relationships" xmlns:p="http://schemas.openxmlformats.org/presentationml/2006/main">
   <p:cSld name="Slide 2">

</xml_diff>